<commit_message>
create semdial 2025 paper
</commit_message>
<xml_diff>
--- a/thesis/figures/schema.pptx
+++ b/thesis/figures/schema.pptx
@@ -318,7 +318,7 @@
 </file>
 
 <file path=ppt/slideLayouts/slideLayout1.xml><?xml version="1.0" encoding="utf-8"?>
-<p:sldLayout xmlns:a="http://schemas.openxmlformats.org/drawingml/2006/main" xmlns:r="http://schemas.openxmlformats.org/officeDocument/2006/relationships" xmlns:p="http://schemas.openxmlformats.org/presentationml/2006/main" xmlns:m="http://schemas.openxmlformats.org/officeDocument/2006/math" xmlns:w="http://schemas.openxmlformats.org/wordprocessingml/2006/main" matchingName="" preserve="0" showMasterPhAnim="0" userDrawn="1">
+<p:sldLayout xmlns:a="http://schemas.openxmlformats.org/drawingml/2006/main" xmlns:r="http://schemas.openxmlformats.org/officeDocument/2006/relationships" xmlns:p="http://schemas.openxmlformats.org/presentationml/2006/main" xmlns:m="http://schemas.openxmlformats.org/officeDocument/2006/math" xmlns:w="http://schemas.openxmlformats.org/wordprocessingml/2006/main" matchingName="" preserve="0" showMasterPhAnim="0" showMasterSp="1" userDrawn="1">
   <p:cSld name="">
     <p:spTree>
       <p:nvGrpSpPr>
@@ -381,7 +381,7 @@
 </file>
 
 <file path=ppt/slides/slide1.xml><?xml version="1.0" encoding="utf-8"?>
-<p:sld xmlns:a="http://schemas.openxmlformats.org/drawingml/2006/main" xmlns:r="http://schemas.openxmlformats.org/officeDocument/2006/relationships" xmlns:p="http://schemas.openxmlformats.org/presentationml/2006/main" xmlns:m="http://schemas.openxmlformats.org/officeDocument/2006/math" xmlns:w="http://schemas.openxmlformats.org/wordprocessingml/2006/main" showMasterPhAnim="0" show="1">
+<p:sld xmlns:a="http://schemas.openxmlformats.org/drawingml/2006/main" xmlns:r="http://schemas.openxmlformats.org/officeDocument/2006/relationships" xmlns:p="http://schemas.openxmlformats.org/presentationml/2006/main" xmlns:m="http://schemas.openxmlformats.org/officeDocument/2006/math" xmlns:w="http://schemas.openxmlformats.org/wordprocessingml/2006/main" xmlns:mc="http://schemas.openxmlformats.org/markup-compatibility/2006" showMasterPhAnim="0" showMasterSp="1" show="1">
   <p:cSld name="Slide_1">
     <p:spTree>
       <p:nvGrpSpPr>
@@ -2206,7 +2206,7 @@
 </file>
 
 <file path=ppt/slides/slide10.xml><?xml version="1.0" encoding="utf-8"?>
-<p:sld xmlns:a="http://schemas.openxmlformats.org/drawingml/2006/main" xmlns:r="http://schemas.openxmlformats.org/officeDocument/2006/relationships" xmlns:p="http://schemas.openxmlformats.org/presentationml/2006/main" xmlns:m="http://schemas.openxmlformats.org/officeDocument/2006/math" xmlns:w="http://schemas.openxmlformats.org/wordprocessingml/2006/main" showMasterPhAnim="0" show="1">
+<p:sld xmlns:a="http://schemas.openxmlformats.org/drawingml/2006/main" xmlns:r="http://schemas.openxmlformats.org/officeDocument/2006/relationships" xmlns:p="http://schemas.openxmlformats.org/presentationml/2006/main" xmlns:m="http://schemas.openxmlformats.org/officeDocument/2006/math" xmlns:w="http://schemas.openxmlformats.org/wordprocessingml/2006/main" xmlns:mc="http://schemas.openxmlformats.org/markup-compatibility/2006" showMasterPhAnim="0" showMasterSp="1" show="1">
   <p:cSld name="Slide_1">
     <p:spTree>
       <p:nvGrpSpPr>
@@ -2301,7 +2301,7 @@
         <p:spPr bwMode="auto">
           <a:xfrm>
             <a:off x="5759636" y="1761728"/>
-            <a:ext cx="679276" cy="610160"/>
+            <a:ext cx="679275" cy="610160"/>
           </a:xfrm>
           <a:prstGeom prst="rect">
             <a:avLst/>
@@ -2535,7 +2535,7 @@
         </p:nvSpPr>
         <p:spPr bwMode="auto">
           <a:xfrm>
-            <a:off x="6033218" y="3261753"/>
+            <a:off x="6033218" y="3261752"/>
             <a:ext cx="226820" cy="208317"/>
           </a:xfrm>
           <a:prstGeom prst="rect">
@@ -2764,7 +2764,7 @@
           <p:nvPr/>
         </p:nvSpPr>
         <p:spPr bwMode="auto">
-          <a:xfrm rot="18899906">
+          <a:xfrm rot="18899905">
             <a:off x="6930720" y="2238097"/>
             <a:ext cx="507567" cy="305151"/>
           </a:xfrm>
@@ -3161,7 +3161,7 @@
         <p:spPr bwMode="auto">
           <a:xfrm>
             <a:off x="3880554" y="1757048"/>
-            <a:ext cx="679276" cy="610160"/>
+            <a:ext cx="679275" cy="610160"/>
           </a:xfrm>
           <a:prstGeom prst="rect">
             <a:avLst/>
@@ -4133,7 +4133,7 @@
         <p:spPr bwMode="auto">
           <a:xfrm>
             <a:off x="2513720" y="1757048"/>
-            <a:ext cx="679276" cy="610160"/>
+            <a:ext cx="679275" cy="610160"/>
           </a:xfrm>
           <a:prstGeom prst="rect">
             <a:avLst/>
@@ -4407,7 +4407,7 @@
         <p:spPr bwMode="auto">
           <a:xfrm>
             <a:off x="4218933" y="3433462"/>
-            <a:ext cx="0" cy="252703"/>
+            <a:ext cx="0" cy="252702"/>
           </a:xfrm>
           <a:prstGeom prst="line">
             <a:avLst/>
@@ -4439,7 +4439,7 @@
         <p:spPr bwMode="auto">
           <a:xfrm>
             <a:off x="2843099" y="3422664"/>
-            <a:ext cx="0" cy="252703"/>
+            <a:ext cx="0" cy="252702"/>
           </a:xfrm>
           <a:prstGeom prst="line">
             <a:avLst/>
@@ -4522,7 +4522,7 @@
 </file>
 
 <file path=ppt/slides/slide11.xml><?xml version="1.0" encoding="utf-8"?>
-<p:sld xmlns:a="http://schemas.openxmlformats.org/drawingml/2006/main" xmlns:r="http://schemas.openxmlformats.org/officeDocument/2006/relationships" xmlns:p="http://schemas.openxmlformats.org/presentationml/2006/main" xmlns:m="http://schemas.openxmlformats.org/officeDocument/2006/math" xmlns:w="http://schemas.openxmlformats.org/wordprocessingml/2006/main" showMasterPhAnim="0" show="1">
+<p:sld xmlns:a="http://schemas.openxmlformats.org/drawingml/2006/main" xmlns:r="http://schemas.openxmlformats.org/officeDocument/2006/relationships" xmlns:p="http://schemas.openxmlformats.org/presentationml/2006/main" xmlns:m="http://schemas.openxmlformats.org/officeDocument/2006/math" xmlns:w="http://schemas.openxmlformats.org/wordprocessingml/2006/main" xmlns:mc="http://schemas.openxmlformats.org/markup-compatibility/2006" showMasterPhAnim="0" showMasterSp="1" show="1">
   <p:cSld name="Slide_8">
     <p:spTree>
       <p:nvGrpSpPr>
@@ -6816,7 +6816,7 @@
 </file>
 
 <file path=ppt/slides/slide12.xml><?xml version="1.0" encoding="utf-8"?>
-<p:sld xmlns:a="http://schemas.openxmlformats.org/drawingml/2006/main" xmlns:r="http://schemas.openxmlformats.org/officeDocument/2006/relationships" xmlns:p="http://schemas.openxmlformats.org/presentationml/2006/main" xmlns:m="http://schemas.openxmlformats.org/officeDocument/2006/math" xmlns:w="http://schemas.openxmlformats.org/wordprocessingml/2006/main" showMasterPhAnim="0" show="1">
+<p:sld xmlns:a="http://schemas.openxmlformats.org/drawingml/2006/main" xmlns:r="http://schemas.openxmlformats.org/officeDocument/2006/relationships" xmlns:p="http://schemas.openxmlformats.org/presentationml/2006/main" xmlns:m="http://schemas.openxmlformats.org/officeDocument/2006/math" xmlns:w="http://schemas.openxmlformats.org/wordprocessingml/2006/main" xmlns:mc="http://schemas.openxmlformats.org/markup-compatibility/2006" showMasterPhAnim="0" showMasterSp="1" show="1">
   <p:cSld name="Slide_9">
     <p:spTree>
       <p:nvGrpSpPr>
@@ -7297,8 +7297,8 @@
         </p:nvSpPr>
         <p:spPr bwMode="auto">
           <a:xfrm>
-            <a:off x="6274404" y="3948951"/>
-            <a:ext cx="1228602" cy="239995"/>
+            <a:off x="6274404" y="3948950"/>
+            <a:ext cx="1239401" cy="240007"/>
           </a:xfrm>
           <a:prstGeom prst="rect">
             <a:avLst/>
@@ -7318,12 +7318,1443 @@
           </a:bodyPr>
           <a:lstStyle/>
           <a:p>
-            <a:pPr marL="0" algn="ctr">
+            <a:pPr marL="0" algn="l">
               <a:lnSpc>
                 <a:spcPct val="100000"/>
               </a:lnSpc>
               <a:defRPr/>
             </a:pPr>
+            <a:r>
+              <a:rPr sz="1100" strike="noStrike">
+                <a:solidFill>
+                  <a:srgbClr val="000000"/>
+                </a:solidFill>
+                <a:latin typeface="Cantarell"/>
+                <a:cs typeface="Cantarell"/>
+              </a:rPr>
+              <a:t>     m</a:t>
+            </a:r>
+            <a:r>
+              <a:rPr sz="1100" strike="noStrike" baseline="-25000">
+                <a:solidFill>
+                  <a:srgbClr val="000000"/>
+                </a:solidFill>
+                <a:latin typeface="Cantarell"/>
+                <a:cs typeface="Cantarell"/>
+              </a:rPr>
+              <a:t>0       </a:t>
+            </a:r>
+            <a:r>
+              <a:rPr sz="1100" strike="noStrike">
+                <a:solidFill>
+                  <a:srgbClr val="000000"/>
+                </a:solidFill>
+                <a:latin typeface="Cantarell"/>
+                <a:cs typeface="Cantarell"/>
+              </a:rPr>
+              <a:t> m</a:t>
+            </a:r>
+            <a:r>
+              <a:rPr sz="1100" strike="noStrike" baseline="-25000">
+                <a:solidFill>
+                  <a:srgbClr val="000000"/>
+                </a:solidFill>
+                <a:latin typeface="Cantarell"/>
+                <a:cs typeface="Cantarell"/>
+              </a:rPr>
+              <a:t>1    </a:t>
+            </a:r>
+            <a:r>
+              <a:rPr sz="1100" strike="noStrike">
+                <a:solidFill>
+                  <a:srgbClr val="000000"/>
+                </a:solidFill>
+                <a:latin typeface="Cantarell"/>
+                <a:cs typeface="Cantarell"/>
+              </a:rPr>
+              <a:t>&lt;eos&gt;</a:t>
+            </a:r>
+            <a:endParaRPr/>
+          </a:p>
+        </p:txBody>
+      </p:sp>
+      <p:sp>
+        <p:nvSpPr>
+          <p:cNvPr id="15" name=""/>
+          <p:cNvSpPr/>
+          <p:nvPr/>
+        </p:nvSpPr>
+        <p:spPr bwMode="auto">
+          <a:xfrm>
+            <a:off x="3974149" y="3428784"/>
+            <a:ext cx="381575" cy="359"/>
+          </a:xfrm>
+          <a:prstGeom prst="line">
+            <a:avLst/>
+          </a:prstGeom>
+          <a:ln w="12700">
+            <a:solidFill>
+              <a:srgbClr val="000000"/>
+            </a:solidFill>
+            <a:tailEnd type="triangle"/>
+          </a:ln>
+          <a:effectLst/>
+        </p:spPr>
+        <p:txBody>
+          <a:bodyPr/>
+          <a:lstStyle/>
+          <a:p>
+            <a:pPr>
+              <a:defRPr/>
+            </a:pPr>
+            <a:endParaRPr/>
+          </a:p>
+        </p:txBody>
+      </p:sp>
+      <p:sp>
+        <p:nvSpPr>
+          <p:cNvPr id="16" name=""/>
+          <p:cNvSpPr txBox="1"/>
+          <p:nvPr/>
+        </p:nvSpPr>
+        <p:spPr bwMode="auto">
+          <a:xfrm>
+            <a:off x="3995748" y="3175000"/>
+            <a:ext cx="434852" cy="305152"/>
+          </a:xfrm>
+          <a:prstGeom prst="rect">
+            <a:avLst/>
+          </a:prstGeom>
+          <a:noFill/>
+          <a:ln>
+            <a:noFill/>
+          </a:ln>
+          <a:effectLst/>
+        </p:spPr>
+        <p:txBody>
+          <a:bodyPr lIns="91440" tIns="45720" rIns="91440" bIns="45720" anchor="t">
+            <a:spAutoFit/>
+          </a:bodyPr>
+          <a:lstStyle/>
+          <a:p>
+            <a:pPr>
+              <a:defRPr/>
+            </a:pPr>
+            <a:r>
+              <a:rPr sz="1400"/>
+              <a:t>h</a:t>
+            </a:r>
+            <a:r>
+              <a:rPr sz="1400" baseline="-25000"/>
+              <a:t>0</a:t>
+            </a:r>
+            <a:endParaRPr/>
+          </a:p>
+        </p:txBody>
+      </p:sp>
+      <p:sp>
+        <p:nvSpPr>
+          <p:cNvPr id="17" name=""/>
+          <p:cNvSpPr txBox="1"/>
+          <p:nvPr/>
+        </p:nvSpPr>
+        <p:spPr bwMode="auto">
+          <a:xfrm>
+            <a:off x="6436394" y="3117763"/>
+            <a:ext cx="883024" cy="603321"/>
+          </a:xfrm>
+          <a:prstGeom prst="rect">
+            <a:avLst/>
+          </a:prstGeom>
+          <a:noFill/>
+          <a:ln w="12700">
+            <a:solidFill>
+              <a:srgbClr val="000000"/>
+            </a:solidFill>
+          </a:ln>
+          <a:effectLst/>
+        </p:spPr>
+        <p:txBody>
+          <a:bodyPr lIns="91440" tIns="45720" rIns="91440" bIns="45720" anchor="ctr"/>
+          <a:lstStyle/>
+          <a:p>
+            <a:pPr marL="0" algn="ctr">
+              <a:defRPr/>
+            </a:pPr>
+            <a:r>
+              <a:rPr sz="1400" strike="noStrike">
+                <a:latin typeface="Cantarell"/>
+                <a:cs typeface="Cantarell"/>
+              </a:rPr>
+              <a:t>RNN</a:t>
+            </a:r>
+            <a:endParaRPr/>
+          </a:p>
+        </p:txBody>
+      </p:sp>
+      <p:sp>
+        <p:nvSpPr>
+          <p:cNvPr id="18" name=""/>
+          <p:cNvSpPr/>
+          <p:nvPr/>
+        </p:nvSpPr>
+        <p:spPr bwMode="auto">
+          <a:xfrm flipV="1">
+            <a:off x="6537188" y="3768962"/>
+            <a:ext cx="0" cy="151190"/>
+          </a:xfrm>
+          <a:prstGeom prst="line">
+            <a:avLst/>
+          </a:prstGeom>
+          <a:ln w="12700">
+            <a:solidFill>
+              <a:srgbClr val="000000"/>
+            </a:solidFill>
+            <a:tailEnd type="triangle"/>
+          </a:ln>
+          <a:effectLst/>
+        </p:spPr>
+        <p:txBody>
+          <a:bodyPr/>
+          <a:lstStyle/>
+          <a:p>
+            <a:pPr>
+              <a:defRPr/>
+            </a:pPr>
+            <a:endParaRPr/>
+          </a:p>
+        </p:txBody>
+      </p:sp>
+      <p:sp>
+        <p:nvSpPr>
+          <p:cNvPr id="19" name=""/>
+          <p:cNvSpPr/>
+          <p:nvPr/>
+        </p:nvSpPr>
+        <p:spPr bwMode="auto">
+          <a:xfrm>
+            <a:off x="7318339" y="3419424"/>
+            <a:ext cx="341978" cy="0"/>
+          </a:xfrm>
+          <a:prstGeom prst="line">
+            <a:avLst/>
+          </a:prstGeom>
+          <a:ln w="12700">
+            <a:solidFill>
+              <a:srgbClr val="000000"/>
+            </a:solidFill>
+            <a:tailEnd type="triangle"/>
+          </a:ln>
+          <a:effectLst/>
+        </p:spPr>
+        <p:txBody>
+          <a:bodyPr/>
+          <a:lstStyle/>
+          <a:p>
+            <a:pPr>
+              <a:defRPr/>
+            </a:pPr>
+            <a:endParaRPr/>
+          </a:p>
+        </p:txBody>
+      </p:sp>
+      <p:sp>
+        <p:nvSpPr>
+          <p:cNvPr id="20" name=""/>
+          <p:cNvSpPr/>
+          <p:nvPr/>
+        </p:nvSpPr>
+        <p:spPr bwMode="auto">
+          <a:xfrm flipV="1">
+            <a:off x="6537188" y="2964413"/>
+            <a:ext cx="0" cy="151550"/>
+          </a:xfrm>
+          <a:prstGeom prst="line">
+            <a:avLst/>
+          </a:prstGeom>
+          <a:ln w="12700">
+            <a:solidFill>
+              <a:srgbClr val="000000"/>
+            </a:solidFill>
+            <a:tailEnd type="triangle"/>
+          </a:ln>
+          <a:effectLst/>
+        </p:spPr>
+        <p:txBody>
+          <a:bodyPr/>
+          <a:lstStyle/>
+          <a:p>
+            <a:pPr>
+              <a:defRPr/>
+            </a:pPr>
+            <a:endParaRPr/>
+          </a:p>
+        </p:txBody>
+      </p:sp>
+      <p:sp>
+        <p:nvSpPr>
+          <p:cNvPr id="21" name=""/>
+          <p:cNvSpPr/>
+          <p:nvPr/>
+        </p:nvSpPr>
+        <p:spPr bwMode="auto">
+          <a:xfrm flipV="1">
+            <a:off x="6875566" y="2964413"/>
+            <a:ext cx="0" cy="151550"/>
+          </a:xfrm>
+          <a:prstGeom prst="line">
+            <a:avLst/>
+          </a:prstGeom>
+          <a:ln w="12700">
+            <a:solidFill>
+              <a:srgbClr val="000000"/>
+            </a:solidFill>
+            <a:tailEnd type="triangle"/>
+          </a:ln>
+          <a:effectLst/>
+        </p:spPr>
+        <p:txBody>
+          <a:bodyPr/>
+          <a:lstStyle/>
+          <a:p>
+            <a:pPr>
+              <a:defRPr/>
+            </a:pPr>
+            <a:endParaRPr/>
+          </a:p>
+        </p:txBody>
+      </p:sp>
+      <p:sp>
+        <p:nvSpPr>
+          <p:cNvPr id="22" name=""/>
+          <p:cNvSpPr/>
+          <p:nvPr/>
+        </p:nvSpPr>
+        <p:spPr bwMode="auto">
+          <a:xfrm flipV="1">
+            <a:off x="7217545" y="2968732"/>
+            <a:ext cx="0" cy="151550"/>
+          </a:xfrm>
+          <a:prstGeom prst="line">
+            <a:avLst/>
+          </a:prstGeom>
+          <a:ln w="12700">
+            <a:solidFill>
+              <a:srgbClr val="000000"/>
+            </a:solidFill>
+            <a:tailEnd type="triangle"/>
+          </a:ln>
+          <a:effectLst/>
+        </p:spPr>
+        <p:txBody>
+          <a:bodyPr/>
+          <a:lstStyle/>
+          <a:p>
+            <a:pPr>
+              <a:defRPr/>
+            </a:pPr>
+            <a:endParaRPr/>
+          </a:p>
+        </p:txBody>
+      </p:sp>
+      <p:sp>
+        <p:nvSpPr>
+          <p:cNvPr id="23" name=""/>
+          <p:cNvSpPr/>
+          <p:nvPr/>
+        </p:nvSpPr>
+        <p:spPr bwMode="auto">
+          <a:xfrm flipV="1">
+            <a:off x="4802097" y="3783361"/>
+            <a:ext cx="0" cy="151190"/>
+          </a:xfrm>
+          <a:prstGeom prst="line">
+            <a:avLst/>
+          </a:prstGeom>
+          <a:ln w="12700">
+            <a:solidFill>
+              <a:srgbClr val="000000"/>
+            </a:solidFill>
+            <a:tailEnd type="triangle"/>
+          </a:ln>
+          <a:effectLst/>
+        </p:spPr>
+        <p:txBody>
+          <a:bodyPr/>
+          <a:lstStyle/>
+          <a:p>
+            <a:pPr>
+              <a:defRPr/>
+            </a:pPr>
+            <a:endParaRPr/>
+          </a:p>
+        </p:txBody>
+      </p:sp>
+      <p:sp>
+        <p:nvSpPr>
+          <p:cNvPr id="24" name=""/>
+          <p:cNvSpPr/>
+          <p:nvPr/>
+        </p:nvSpPr>
+        <p:spPr bwMode="auto">
+          <a:xfrm flipV="1">
+            <a:off x="5140476" y="3772562"/>
+            <a:ext cx="0" cy="151190"/>
+          </a:xfrm>
+          <a:prstGeom prst="line">
+            <a:avLst/>
+          </a:prstGeom>
+          <a:ln w="12700">
+            <a:solidFill>
+              <a:srgbClr val="000000"/>
+            </a:solidFill>
+            <a:tailEnd type="triangle"/>
+          </a:ln>
+          <a:effectLst/>
+        </p:spPr>
+        <p:txBody>
+          <a:bodyPr/>
+          <a:lstStyle/>
+          <a:p>
+            <a:pPr>
+              <a:defRPr/>
+            </a:pPr>
+            <a:endParaRPr/>
+          </a:p>
+        </p:txBody>
+      </p:sp>
+      <p:sp>
+        <p:nvSpPr>
+          <p:cNvPr id="25" name=""/>
+          <p:cNvSpPr/>
+          <p:nvPr/>
+        </p:nvSpPr>
+        <p:spPr bwMode="auto">
+          <a:xfrm flipV="1">
+            <a:off x="6875566" y="3768962"/>
+            <a:ext cx="0" cy="151190"/>
+          </a:xfrm>
+          <a:prstGeom prst="line">
+            <a:avLst/>
+          </a:prstGeom>
+          <a:ln w="12700">
+            <a:solidFill>
+              <a:srgbClr val="000000"/>
+            </a:solidFill>
+            <a:tailEnd type="triangle"/>
+          </a:ln>
+          <a:effectLst/>
+        </p:spPr>
+        <p:txBody>
+          <a:bodyPr/>
+          <a:lstStyle/>
+          <a:p>
+            <a:pPr>
+              <a:defRPr/>
+            </a:pPr>
+            <a:endParaRPr/>
+          </a:p>
+        </p:txBody>
+      </p:sp>
+      <p:sp>
+        <p:nvSpPr>
+          <p:cNvPr id="26" name=""/>
+          <p:cNvSpPr/>
+          <p:nvPr/>
+        </p:nvSpPr>
+        <p:spPr bwMode="auto">
+          <a:xfrm flipV="1">
+            <a:off x="7217545" y="3772562"/>
+            <a:ext cx="0" cy="151190"/>
+          </a:xfrm>
+          <a:prstGeom prst="line">
+            <a:avLst/>
+          </a:prstGeom>
+          <a:ln w="12700">
+            <a:solidFill>
+              <a:srgbClr val="000000"/>
+            </a:solidFill>
+            <a:tailEnd type="triangle"/>
+          </a:ln>
+          <a:effectLst/>
+        </p:spPr>
+        <p:txBody>
+          <a:bodyPr/>
+          <a:lstStyle/>
+          <a:p>
+            <a:pPr>
+              <a:defRPr/>
+            </a:pPr>
+            <a:endParaRPr/>
+          </a:p>
+        </p:txBody>
+      </p:sp>
+      <p:sp>
+        <p:nvSpPr>
+          <p:cNvPr id="27" name=""/>
+          <p:cNvSpPr/>
+          <p:nvPr/>
+        </p:nvSpPr>
+        <p:spPr bwMode="auto">
+          <a:xfrm>
+            <a:off x="5799234" y="4074943"/>
+            <a:ext cx="475170" cy="0"/>
+          </a:xfrm>
+          <a:prstGeom prst="line">
+            <a:avLst/>
+          </a:prstGeom>
+          <a:ln w="19050">
+            <a:solidFill>
+              <a:srgbClr val="205967"/>
+            </a:solidFill>
+            <a:tailEnd type="triangle"/>
+          </a:ln>
+          <a:effectLst/>
+        </p:spPr>
+        <p:txBody>
+          <a:bodyPr/>
+          <a:lstStyle/>
+          <a:p>
+            <a:pPr>
+              <a:defRPr/>
+            </a:pPr>
+            <a:endParaRPr/>
+          </a:p>
+        </p:txBody>
+      </p:sp>
+      <p:sp>
+        <p:nvSpPr>
+          <p:cNvPr id="28" name=""/>
+          <p:cNvSpPr/>
+          <p:nvPr/>
+        </p:nvSpPr>
+        <p:spPr bwMode="auto">
+          <a:xfrm>
+            <a:off x="5424857" y="2860738"/>
+            <a:ext cx="392375" cy="0"/>
+          </a:xfrm>
+          <a:prstGeom prst="line">
+            <a:avLst/>
+          </a:prstGeom>
+          <a:ln w="19050">
+            <a:solidFill>
+              <a:srgbClr val="205967"/>
+            </a:solidFill>
+          </a:ln>
+          <a:effectLst/>
+        </p:spPr>
+        <p:txBody>
+          <a:bodyPr/>
+          <a:lstStyle/>
+          <a:p>
+            <a:pPr>
+              <a:defRPr/>
+            </a:pPr>
+            <a:endParaRPr/>
+          </a:p>
+        </p:txBody>
+      </p:sp>
+      <p:sp>
+        <p:nvSpPr>
+          <p:cNvPr id="29" name=""/>
+          <p:cNvSpPr/>
+          <p:nvPr/>
+        </p:nvSpPr>
+        <p:spPr bwMode="auto">
+          <a:xfrm>
+            <a:off x="5817233" y="2863619"/>
+            <a:ext cx="0" cy="1207723"/>
+          </a:xfrm>
+          <a:prstGeom prst="line">
+            <a:avLst/>
+          </a:prstGeom>
+          <a:ln w="19050">
+            <a:solidFill>
+              <a:srgbClr val="205967"/>
+            </a:solidFill>
+          </a:ln>
+          <a:effectLst/>
+        </p:spPr>
+        <p:txBody>
+          <a:bodyPr/>
+          <a:lstStyle/>
+          <a:p>
+            <a:pPr>
+              <a:defRPr/>
+            </a:pPr>
+            <a:endParaRPr/>
+          </a:p>
+        </p:txBody>
+      </p:sp>
+      <p:sp>
+        <p:nvSpPr>
+          <p:cNvPr id="30" name=""/>
+          <p:cNvSpPr txBox="1"/>
+          <p:nvPr/>
+        </p:nvSpPr>
+        <p:spPr bwMode="auto">
+          <a:xfrm>
+            <a:off x="5774036" y="3244475"/>
+            <a:ext cx="435932" cy="335642"/>
+          </a:xfrm>
+          <a:prstGeom prst="rect">
+            <a:avLst/>
+          </a:prstGeom>
+          <a:noFill/>
+          <a:ln>
+            <a:noFill/>
+          </a:ln>
+          <a:effectLst/>
+        </p:spPr>
+        <p:txBody>
+          <a:bodyPr lIns="91440" tIns="45720" rIns="91440" bIns="45720" anchor="t">
+            <a:spAutoFit/>
+          </a:bodyPr>
+          <a:lstStyle/>
+          <a:p>
+            <a:pPr>
+              <a:defRPr/>
+            </a:pPr>
+            <a:r>
+              <a:rPr sz="1600"/>
+              <a:t>m</a:t>
+            </a:r>
+            <a:endParaRPr/>
+          </a:p>
+        </p:txBody>
+      </p:sp>
+      <p:sp>
+        <p:nvSpPr>
+          <p:cNvPr id="31" name=""/>
+          <p:cNvSpPr txBox="1"/>
+          <p:nvPr/>
+        </p:nvSpPr>
+        <p:spPr bwMode="auto">
+          <a:xfrm>
+            <a:off x="7307539" y="3163840"/>
+            <a:ext cx="435932" cy="305152"/>
+          </a:xfrm>
+          <a:prstGeom prst="rect">
+            <a:avLst/>
+          </a:prstGeom>
+          <a:noFill/>
+          <a:ln>
+            <a:noFill/>
+          </a:ln>
+          <a:effectLst/>
+        </p:spPr>
+        <p:txBody>
+          <a:bodyPr lIns="91440" tIns="45720" rIns="91440" bIns="45720" anchor="t">
+            <a:spAutoFit/>
+          </a:bodyPr>
+          <a:lstStyle/>
+          <a:p>
+            <a:pPr>
+              <a:defRPr/>
+            </a:pPr>
+            <a:r>
+              <a:rPr sz="1400"/>
+              <a:t>h</a:t>
+            </a:r>
+            <a:r>
+              <a:rPr sz="1400" baseline="-25000"/>
+              <a:t>n</a:t>
+            </a:r>
+            <a:endParaRPr/>
+          </a:p>
+        </p:txBody>
+      </p:sp>
+      <p:sp>
+        <p:nvSpPr>
+          <p:cNvPr id="32" name=""/>
+          <p:cNvSpPr txBox="1"/>
+          <p:nvPr/>
+        </p:nvSpPr>
+        <p:spPr bwMode="auto">
+          <a:xfrm>
+            <a:off x="4899291" y="1895640"/>
+            <a:ext cx="1852443" cy="335642"/>
+          </a:xfrm>
+          <a:prstGeom prst="rect">
+            <a:avLst/>
+          </a:prstGeom>
+          <a:noFill/>
+          <a:ln>
+            <a:noFill/>
+          </a:ln>
+          <a:effectLst/>
+        </p:spPr>
+        <p:txBody>
+          <a:bodyPr lIns="91440" tIns="45720" rIns="91440" bIns="45720" anchor="t">
+            <a:spAutoFit/>
+          </a:bodyPr>
+          <a:lstStyle/>
+          <a:p>
+            <a:pPr algn="ctr">
+              <a:defRPr/>
+            </a:pPr>
+            <a:r>
+              <a:rPr sz="1600" b="1"/>
+              <a:t>INPUT</a:t>
+            </a:r>
+            <a:endParaRPr/>
+          </a:p>
+        </p:txBody>
+      </p:sp>
+      <p:sp>
+        <p:nvSpPr>
+          <p:cNvPr id="33" name=""/>
+          <p:cNvSpPr txBox="1"/>
+          <p:nvPr/>
+        </p:nvSpPr>
+        <p:spPr bwMode="auto">
+          <a:xfrm>
+            <a:off x="5054081" y="4571712"/>
+            <a:ext cx="1543222" cy="579563"/>
+          </a:xfrm>
+          <a:prstGeom prst="rect">
+            <a:avLst/>
+          </a:prstGeom>
+          <a:noFill/>
+          <a:ln>
+            <a:noFill/>
+          </a:ln>
+          <a:effectLst/>
+        </p:spPr>
+        <p:txBody>
+          <a:bodyPr lIns="91440" tIns="45720" rIns="91440" bIns="45720" anchor="t">
+            <a:spAutoFit/>
+          </a:bodyPr>
+          <a:lstStyle/>
+          <a:p>
+            <a:pPr algn="ctr">
+              <a:defRPr/>
+            </a:pPr>
+            <a:r>
+              <a:rPr sz="1600" b="1"/>
+              <a:t>GROUND TRUTH</a:t>
+            </a:r>
+            <a:endParaRPr/>
+          </a:p>
+        </p:txBody>
+      </p:sp>
+      <p:sp>
+        <p:nvSpPr>
+          <p:cNvPr id="49" name=""/>
+          <p:cNvSpPr/>
+          <p:nvPr/>
+        </p:nvSpPr>
+        <p:spPr bwMode="auto">
+          <a:xfrm>
+            <a:off x="7779109" y="3153761"/>
+            <a:ext cx="214294" cy="214294"/>
+          </a:xfrm>
+          <a:prstGeom prst="ellipse">
+            <a:avLst/>
+          </a:prstGeom>
+          <a:noFill/>
+          <a:ln w="12700">
+            <a:solidFill>
+              <a:srgbClr val="000000"/>
+            </a:solidFill>
+          </a:ln>
+          <a:effectLst/>
+        </p:spPr>
+        <p:txBody>
+          <a:bodyPr/>
+          <a:lstStyle/>
+          <a:p>
+            <a:pPr>
+              <a:defRPr/>
+            </a:pPr>
+            <a:endParaRPr/>
+          </a:p>
+        </p:txBody>
+      </p:sp>
+      <p:sp>
+        <p:nvSpPr>
+          <p:cNvPr id="50" name=""/>
+          <p:cNvSpPr/>
+          <p:nvPr/>
+        </p:nvSpPr>
+        <p:spPr bwMode="auto">
+          <a:xfrm>
+            <a:off x="7779109" y="3489620"/>
+            <a:ext cx="214294" cy="214294"/>
+          </a:xfrm>
+          <a:prstGeom prst="ellipse">
+            <a:avLst/>
+          </a:prstGeom>
+          <a:noFill/>
+          <a:ln w="12700">
+            <a:solidFill>
+              <a:srgbClr val="000000"/>
+            </a:solidFill>
+          </a:ln>
+          <a:effectLst/>
+        </p:spPr>
+        <p:txBody>
+          <a:bodyPr/>
+          <a:lstStyle/>
+          <a:p>
+            <a:pPr>
+              <a:defRPr/>
+            </a:pPr>
+            <a:endParaRPr/>
+          </a:p>
+        </p:txBody>
+      </p:sp>
+      <p:sp>
+        <p:nvSpPr>
+          <p:cNvPr id="51" name=""/>
+          <p:cNvSpPr/>
+          <p:nvPr/>
+        </p:nvSpPr>
+        <p:spPr bwMode="auto">
+          <a:xfrm>
+            <a:off x="8067091" y="3320790"/>
+            <a:ext cx="214294" cy="214294"/>
+          </a:xfrm>
+          <a:prstGeom prst="ellipse">
+            <a:avLst/>
+          </a:prstGeom>
+          <a:noFill/>
+          <a:ln w="12700">
+            <a:solidFill>
+              <a:srgbClr val="000000"/>
+            </a:solidFill>
+          </a:ln>
+          <a:effectLst/>
+        </p:spPr>
+        <p:txBody>
+          <a:bodyPr/>
+          <a:lstStyle/>
+          <a:p>
+            <a:pPr>
+              <a:defRPr/>
+            </a:pPr>
+            <a:endParaRPr/>
+          </a:p>
+        </p:txBody>
+      </p:sp>
+      <p:sp>
+        <p:nvSpPr>
+          <p:cNvPr id="52" name=""/>
+          <p:cNvSpPr/>
+          <p:nvPr/>
+        </p:nvSpPr>
+        <p:spPr bwMode="auto">
+          <a:xfrm>
+            <a:off x="8067091" y="3004730"/>
+            <a:ext cx="214294" cy="214294"/>
+          </a:xfrm>
+          <a:prstGeom prst="ellipse">
+            <a:avLst/>
+          </a:prstGeom>
+          <a:noFill/>
+          <a:ln w="12700">
+            <a:solidFill>
+              <a:srgbClr val="000000"/>
+            </a:solidFill>
+          </a:ln>
+          <a:effectLst/>
+        </p:spPr>
+        <p:txBody>
+          <a:bodyPr/>
+          <a:lstStyle/>
+          <a:p>
+            <a:pPr>
+              <a:defRPr/>
+            </a:pPr>
+            <a:endParaRPr/>
+          </a:p>
+        </p:txBody>
+      </p:sp>
+      <p:sp>
+        <p:nvSpPr>
+          <p:cNvPr id="53" name=""/>
+          <p:cNvSpPr/>
+          <p:nvPr/>
+        </p:nvSpPr>
+        <p:spPr bwMode="auto">
+          <a:xfrm>
+            <a:off x="8067091" y="3621371"/>
+            <a:ext cx="214294" cy="214294"/>
+          </a:xfrm>
+          <a:prstGeom prst="ellipse">
+            <a:avLst/>
+          </a:prstGeom>
+          <a:noFill/>
+          <a:ln w="12700">
+            <a:solidFill>
+              <a:srgbClr val="000000"/>
+            </a:solidFill>
+          </a:ln>
+          <a:effectLst/>
+        </p:spPr>
+        <p:txBody>
+          <a:bodyPr/>
+          <a:lstStyle/>
+          <a:p>
+            <a:pPr>
+              <a:defRPr/>
+            </a:pPr>
+            <a:endParaRPr/>
+          </a:p>
+        </p:txBody>
+      </p:sp>
+      <p:sp>
+        <p:nvSpPr>
+          <p:cNvPr id="54" name=""/>
+          <p:cNvSpPr/>
+          <p:nvPr/>
+        </p:nvSpPr>
+        <p:spPr bwMode="auto">
+          <a:xfrm>
+            <a:off x="8373072" y="3313591"/>
+            <a:ext cx="214294" cy="214294"/>
+          </a:xfrm>
+          <a:prstGeom prst="ellipse">
+            <a:avLst/>
+          </a:prstGeom>
+          <a:noFill/>
+          <a:ln w="12700">
+            <a:solidFill>
+              <a:srgbClr val="000000"/>
+            </a:solidFill>
+          </a:ln>
+          <a:effectLst/>
+        </p:spPr>
+        <p:txBody>
+          <a:bodyPr/>
+          <a:lstStyle/>
+          <a:p>
+            <a:pPr>
+              <a:defRPr/>
+            </a:pPr>
+            <a:endParaRPr/>
+          </a:p>
+        </p:txBody>
+      </p:sp>
+      <p:sp>
+        <p:nvSpPr>
+          <p:cNvPr id="57" name=""/>
+          <p:cNvSpPr/>
+          <p:nvPr/>
+        </p:nvSpPr>
+        <p:spPr bwMode="auto">
+          <a:xfrm flipV="1">
+            <a:off x="5648044" y="-1163445"/>
+            <a:ext cx="93594" cy="7199"/>
+          </a:xfrm>
+          <a:prstGeom prst="line">
+            <a:avLst/>
+          </a:prstGeom>
+          <a:ln w="12700">
+            <a:solidFill>
+              <a:srgbClr val="000000"/>
+            </a:solidFill>
+          </a:ln>
+          <a:effectLst/>
+        </p:spPr>
+        <p:txBody>
+          <a:bodyPr/>
+          <a:lstStyle/>
+          <a:p>
+            <a:pPr>
+              <a:defRPr/>
+            </a:pPr>
+            <a:endParaRPr/>
+          </a:p>
+        </p:txBody>
+      </p:sp>
+      <p:sp>
+        <p:nvSpPr>
+          <p:cNvPr id="58" name=""/>
+          <p:cNvSpPr/>
+          <p:nvPr/>
+        </p:nvSpPr>
+        <p:spPr bwMode="auto">
+          <a:xfrm>
+            <a:off x="5648044" y="-1156246"/>
+            <a:ext cx="226785" cy="44996"/>
+          </a:xfrm>
+          <a:prstGeom prst="line">
+            <a:avLst/>
+          </a:prstGeom>
+          <a:ln w="12700">
+            <a:solidFill>
+              <a:srgbClr val="000000"/>
+            </a:solidFill>
+          </a:ln>
+          <a:effectLst/>
+        </p:spPr>
+        <p:txBody>
+          <a:bodyPr/>
+          <a:lstStyle/>
+          <a:p>
+            <a:pPr>
+              <a:defRPr/>
+            </a:pPr>
+            <a:endParaRPr/>
+          </a:p>
+        </p:txBody>
+      </p:sp>
+      <p:sp>
+        <p:nvSpPr>
+          <p:cNvPr id="59" name=""/>
+          <p:cNvSpPr/>
+          <p:nvPr/>
+        </p:nvSpPr>
+        <p:spPr bwMode="auto">
+          <a:xfrm>
+            <a:off x="7962698" y="3671768"/>
+            <a:ext cx="104393" cy="57596"/>
+          </a:xfrm>
+          <a:prstGeom prst="line">
+            <a:avLst/>
+          </a:prstGeom>
+          <a:ln w="12700">
+            <a:solidFill>
+              <a:srgbClr val="000000"/>
+            </a:solidFill>
+          </a:ln>
+          <a:effectLst/>
+        </p:spPr>
+        <p:txBody>
+          <a:bodyPr/>
+          <a:lstStyle/>
+          <a:p>
+            <a:pPr>
+              <a:defRPr/>
+            </a:pPr>
+            <a:endParaRPr/>
+          </a:p>
+        </p:txBody>
+      </p:sp>
+      <p:sp>
+        <p:nvSpPr>
+          <p:cNvPr id="61" name=""/>
+          <p:cNvSpPr/>
+          <p:nvPr/>
+        </p:nvSpPr>
+        <p:spPr bwMode="auto">
+          <a:xfrm>
+            <a:off x="5720039" y="-1265679"/>
+            <a:ext cx="154790" cy="1079"/>
+          </a:xfrm>
+          <a:prstGeom prst="line">
+            <a:avLst/>
+          </a:prstGeom>
+          <a:ln w="12700">
+            <a:solidFill>
+              <a:srgbClr val="000000"/>
+            </a:solidFill>
+          </a:ln>
+          <a:effectLst/>
+        </p:spPr>
+        <p:txBody>
+          <a:bodyPr/>
+          <a:lstStyle/>
+          <a:p>
+            <a:pPr>
+              <a:defRPr/>
+            </a:pPr>
+            <a:endParaRPr/>
+          </a:p>
+        </p:txBody>
+      </p:sp>
+      <p:sp>
+        <p:nvSpPr>
+          <p:cNvPr id="63" name=""/>
+          <p:cNvSpPr/>
+          <p:nvPr/>
+        </p:nvSpPr>
+        <p:spPr bwMode="auto">
+          <a:xfrm>
+            <a:off x="8283078" y="3424464"/>
+            <a:ext cx="89993" cy="0"/>
+          </a:xfrm>
+          <a:prstGeom prst="line">
+            <a:avLst/>
+          </a:prstGeom>
+          <a:ln w="12700">
+            <a:solidFill>
+              <a:srgbClr val="000000"/>
+            </a:solidFill>
+          </a:ln>
+          <a:effectLst/>
+        </p:spPr>
+        <p:txBody>
+          <a:bodyPr/>
+          <a:lstStyle/>
+          <a:p>
+            <a:pPr>
+              <a:defRPr/>
+            </a:pPr>
+            <a:endParaRPr/>
+          </a:p>
+        </p:txBody>
+      </p:sp>
+      <p:sp>
+        <p:nvSpPr>
+          <p:cNvPr id="64" name=""/>
+          <p:cNvSpPr/>
+          <p:nvPr/>
+        </p:nvSpPr>
+        <p:spPr bwMode="auto">
+          <a:xfrm>
+            <a:off x="3421584" y="2063390"/>
+            <a:ext cx="0" cy="503608"/>
+          </a:xfrm>
+          <a:prstGeom prst="line">
+            <a:avLst/>
+          </a:prstGeom>
+          <a:ln w="12700">
+            <a:solidFill>
+              <a:srgbClr val="000000"/>
+            </a:solidFill>
+            <a:tailEnd type="triangle"/>
+          </a:ln>
+          <a:effectLst/>
+        </p:spPr>
+        <p:txBody>
+          <a:bodyPr/>
+          <a:lstStyle/>
+          <a:p>
+            <a:pPr>
+              <a:defRPr/>
+            </a:pPr>
+            <a:endParaRPr/>
+          </a:p>
+        </p:txBody>
+      </p:sp>
+      <p:sp>
+        <p:nvSpPr>
+          <p:cNvPr id="65" name=""/>
+          <p:cNvSpPr/>
+          <p:nvPr/>
+        </p:nvSpPr>
+        <p:spPr bwMode="auto">
+          <a:xfrm>
+            <a:off x="8236281" y="2063390"/>
+            <a:ext cx="0" cy="503608"/>
+          </a:xfrm>
+          <a:prstGeom prst="line">
+            <a:avLst/>
+          </a:prstGeom>
+          <a:ln w="12700">
+            <a:solidFill>
+              <a:srgbClr val="000000"/>
+            </a:solidFill>
+            <a:tailEnd type="triangle"/>
+          </a:ln>
+          <a:effectLst/>
+        </p:spPr>
+        <p:txBody>
+          <a:bodyPr/>
+          <a:lstStyle/>
+          <a:p>
+            <a:pPr>
+              <a:defRPr/>
+            </a:pPr>
+            <a:endParaRPr/>
+          </a:p>
+        </p:txBody>
+      </p:sp>
+      <p:sp>
+        <p:nvSpPr>
+          <p:cNvPr id="66" name=""/>
+          <p:cNvSpPr/>
+          <p:nvPr/>
+        </p:nvSpPr>
+        <p:spPr bwMode="auto">
+          <a:xfrm>
+            <a:off x="8236281" y="4071343"/>
+            <a:ext cx="0" cy="413973"/>
+          </a:xfrm>
+          <a:prstGeom prst="line">
+            <a:avLst/>
+          </a:prstGeom>
+          <a:ln w="12700">
+            <a:solidFill>
+              <a:srgbClr val="000000"/>
+            </a:solidFill>
+            <a:tailEnd type="triangle"/>
+          </a:ln>
+          <a:effectLst/>
+        </p:spPr>
+        <p:txBody>
+          <a:bodyPr/>
+          <a:lstStyle/>
+          <a:p>
+            <a:pPr>
+              <a:defRPr/>
+            </a:pPr>
+            <a:endParaRPr/>
+          </a:p>
+        </p:txBody>
+      </p:sp>
+      <p:sp>
+        <p:nvSpPr>
+          <p:cNvPr id="67" name=""/>
+          <p:cNvSpPr/>
+          <p:nvPr/>
+        </p:nvSpPr>
+        <p:spPr bwMode="auto">
+          <a:xfrm>
+            <a:off x="3421944" y="2065549"/>
+            <a:ext cx="1981315" cy="0"/>
+          </a:xfrm>
+          <a:prstGeom prst="line">
+            <a:avLst/>
+          </a:prstGeom>
+          <a:ln w="19050">
+            <a:solidFill>
+              <a:srgbClr val="000000"/>
+            </a:solidFill>
+          </a:ln>
+          <a:effectLst/>
+        </p:spPr>
+        <p:txBody>
+          <a:bodyPr/>
+          <a:lstStyle/>
+          <a:p>
+            <a:pPr>
+              <a:defRPr/>
+            </a:pPr>
+            <a:endParaRPr/>
+          </a:p>
+        </p:txBody>
+      </p:sp>
+      <p:sp>
+        <p:nvSpPr>
+          <p:cNvPr id="68" name=""/>
+          <p:cNvSpPr/>
+          <p:nvPr/>
+        </p:nvSpPr>
+        <p:spPr bwMode="auto">
+          <a:xfrm>
+            <a:off x="6224007" y="2065549"/>
+            <a:ext cx="2012273" cy="0"/>
+          </a:xfrm>
+          <a:prstGeom prst="line">
+            <a:avLst/>
+          </a:prstGeom>
+          <a:ln w="19050">
+            <a:solidFill>
+              <a:srgbClr val="000000"/>
+            </a:solidFill>
+          </a:ln>
+          <a:effectLst/>
+        </p:spPr>
+        <p:txBody>
+          <a:bodyPr/>
+          <a:lstStyle/>
+          <a:p>
+            <a:pPr>
+              <a:defRPr/>
+            </a:pPr>
+            <a:endParaRPr/>
+          </a:p>
+        </p:txBody>
+      </p:sp>
+      <p:sp>
+        <p:nvSpPr>
+          <p:cNvPr id="69" name=""/>
+          <p:cNvSpPr/>
+          <p:nvPr/>
+        </p:nvSpPr>
+        <p:spPr bwMode="auto">
+          <a:xfrm>
+            <a:off x="6436394" y="4863293"/>
+            <a:ext cx="1112329" cy="0"/>
+          </a:xfrm>
+          <a:prstGeom prst="line">
+            <a:avLst/>
+          </a:prstGeom>
+          <a:ln w="12700">
+            <a:solidFill>
+              <a:srgbClr val="000000"/>
+            </a:solidFill>
+            <a:tailEnd type="triangle"/>
+          </a:ln>
+          <a:effectLst/>
+        </p:spPr>
+        <p:txBody>
+          <a:bodyPr/>
+          <a:lstStyle/>
+          <a:p>
+            <a:pPr>
+              <a:defRPr/>
+            </a:pPr>
+            <a:endParaRPr/>
+          </a:p>
+        </p:txBody>
+      </p:sp>
+      <p:sp>
+        <p:nvSpPr>
+          <p:cNvPr id="70" name=""/>
+          <p:cNvSpPr txBox="1"/>
+          <p:nvPr/>
+        </p:nvSpPr>
+        <p:spPr bwMode="auto">
+          <a:xfrm>
+            <a:off x="7613520" y="4571712"/>
+            <a:ext cx="1240121" cy="579563"/>
+          </a:xfrm>
+          <a:prstGeom prst="rect">
+            <a:avLst/>
+          </a:prstGeom>
+          <a:noFill/>
+          <a:ln>
+            <a:noFill/>
+          </a:ln>
+          <a:effectLst/>
+        </p:spPr>
+        <p:txBody>
+          <a:bodyPr lIns="91440" tIns="45720" rIns="91440" bIns="45720" anchor="t">
+            <a:spAutoFit/>
+          </a:bodyPr>
+          <a:lstStyle/>
+          <a:p>
+            <a:pPr algn="ctr">
+              <a:defRPr/>
+            </a:pPr>
+            <a:r>
+              <a:rPr sz="1600" b="1"/>
+              <a:t>LOSS FUNCTION</a:t>
+            </a:r>
+            <a:endParaRPr/>
+          </a:p>
+        </p:txBody>
+      </p:sp>
+      <p:cxnSp>
+        <p:nvCxnSpPr>
+          <p:cNvPr id="71" name=""/>
+          <p:cNvCxnSpPr>
+            <a:cxnSpLocks/>
+            <a:stCxn id="70" idx="3"/>
+          </p:cNvCxnSpPr>
+          <p:nvPr/>
+        </p:nvCxnSpPr>
+        <p:spPr bwMode="auto">
+          <a:xfrm rot="0" flipH="1" flipV="1">
+            <a:off x="8652088" y="3658465"/>
+            <a:ext cx="201552" cy="1203028"/>
+          </a:xfrm>
+          <a:prstGeom prst="curvedConnector4">
+            <a:avLst>
+              <a:gd name="adj1" fmla="val -113419"/>
+              <a:gd name="adj2" fmla="val 97205"/>
+            </a:avLst>
+          </a:prstGeom>
+          <a:ln w="28575">
+            <a:solidFill>
+              <a:srgbClr val="C00000"/>
+            </a:solidFill>
+            <a:prstDash val="dash"/>
+            <a:tailEnd type="triangle"/>
+          </a:ln>
+          <a:effectLst/>
+        </p:spPr>
+      </p:cxnSp>
+      <p:sp>
+        <p:nvSpPr>
+          <p:cNvPr id="72" name=""/>
+          <p:cNvSpPr txBox="1"/>
+          <p:nvPr/>
+        </p:nvSpPr>
+        <p:spPr bwMode="auto">
+          <a:xfrm>
+            <a:off x="8153486" y="4035345"/>
+            <a:ext cx="961859" cy="426933"/>
+          </a:xfrm>
+          <a:prstGeom prst="rect">
+            <a:avLst/>
+          </a:prstGeom>
+          <a:noFill/>
+          <a:ln>
+            <a:noFill/>
+          </a:ln>
+          <a:effectLst/>
+        </p:spPr>
+        <p:txBody>
+          <a:bodyPr lIns="91440" tIns="45720" rIns="91440" bIns="45720" anchor="t">
+            <a:spAutoFit/>
+          </a:bodyPr>
+          <a:lstStyle/>
+          <a:p>
+            <a:pPr algn="r">
+              <a:defRPr/>
+            </a:pPr>
+            <a:r>
+              <a:rPr sz="1100">
+                <a:solidFill>
+                  <a:srgbClr val="C00000"/>
+                </a:solidFill>
+              </a:rPr>
+              <a:t>back-propagation</a:t>
+            </a:r>
+            <a:endParaRPr/>
+          </a:p>
+        </p:txBody>
+      </p:sp>
+      <p:sp>
+        <p:nvSpPr>
+          <p:cNvPr id="73" name=""/>
+          <p:cNvSpPr txBox="1"/>
+          <p:nvPr/>
+        </p:nvSpPr>
+        <p:spPr bwMode="auto">
+          <a:xfrm>
+            <a:off x="4197334" y="2737626"/>
+            <a:ext cx="1236161" cy="240007"/>
+          </a:xfrm>
+          <a:prstGeom prst="rect">
+            <a:avLst/>
+          </a:prstGeom>
+          <a:noFill/>
+          <a:ln w="19050">
+            <a:solidFill>
+              <a:srgbClr val="205967"/>
+            </a:solidFill>
+            <a:prstDash val="dash"/>
+          </a:ln>
+          <a:effectLst/>
+        </p:spPr>
+        <p:txBody>
+          <a:bodyPr lIns="36004" tIns="36004" rIns="36004" bIns="36004" anchor="t">
+            <a:spAutoFit/>
+          </a:bodyPr>
+          <a:lstStyle/>
+          <a:p>
+            <a:pPr marL="0" algn="l">
+              <a:lnSpc>
+                <a:spcPct val="100000"/>
+              </a:lnSpc>
+              <a:defRPr/>
+            </a:pPr>
+            <a:r>
+              <a:rPr sz="1100" strike="noStrike">
+                <a:solidFill>
+                  <a:srgbClr val="000000"/>
+                </a:solidFill>
+                <a:latin typeface="Cantarell"/>
+                <a:cs typeface="Cantarell"/>
+              </a:rPr>
+              <a:t>     m</a:t>
+            </a:r>
+            <a:r>
+              <a:rPr sz="1100" strike="noStrike" baseline="-25000">
+                <a:solidFill>
+                  <a:srgbClr val="000000"/>
+                </a:solidFill>
+                <a:latin typeface="Cantarell"/>
+                <a:cs typeface="Cantarell"/>
+              </a:rPr>
+              <a:t>0        </a:t>
+            </a:r>
             <a:r>
               <a:rPr sz="1100" strike="noStrike">
                 <a:solidFill>
@@ -7342,46 +8773,8 @@
                 <a:latin typeface="Cantarell"/>
                 <a:cs typeface="Cantarell"/>
               </a:rPr>
-              <a:t>0</a:t>
+              <a:t>1    </a:t>
             </a:r>
-            <a:endParaRPr/>
-          </a:p>
-          <a:p>
-            <a:pPr marL="0" algn="ctr">
-              <a:lnSpc>
-                <a:spcPct val="100000"/>
-              </a:lnSpc>
-              <a:defRPr/>
-            </a:pPr>
-            <a:r>
-              <a:rPr sz="1100" strike="noStrike">
-                <a:solidFill>
-                  <a:srgbClr val="000000"/>
-                </a:solidFill>
-                <a:latin typeface="Cantarell"/>
-                <a:cs typeface="Cantarell"/>
-              </a:rPr>
-              <a:t>m</a:t>
-            </a:r>
-            <a:r>
-              <a:rPr sz="1100" strike="noStrike" baseline="-25000">
-                <a:solidFill>
-                  <a:srgbClr val="000000"/>
-                </a:solidFill>
-                <a:latin typeface="Cantarell"/>
-                <a:cs typeface="Cantarell"/>
-              </a:rPr>
-              <a:t>1</a:t>
-            </a:r>
-            <a:endParaRPr/>
-          </a:p>
-          <a:p>
-            <a:pPr marL="0" algn="ctr">
-              <a:lnSpc>
-                <a:spcPct val="100000"/>
-              </a:lnSpc>
-              <a:defRPr/>
-            </a:pPr>
             <a:r>
               <a:rPr sz="1100" strike="noStrike">
                 <a:solidFill>
@@ -7398,14 +8791,14 @@
       </p:sp>
       <p:sp>
         <p:nvSpPr>
-          <p:cNvPr id="15" name=""/>
-          <p:cNvSpPr/>
-          <p:nvPr/>
-        </p:nvSpPr>
-        <p:spPr bwMode="auto">
-          <a:xfrm>
-            <a:off x="3974149" y="3428784"/>
-            <a:ext cx="381575" cy="359"/>
+          <p:cNvPr id="74" name=""/>
+          <p:cNvSpPr/>
+          <p:nvPr/>
+        </p:nvSpPr>
+        <p:spPr bwMode="auto">
+          <a:xfrm>
+            <a:off x="6274404" y="3434183"/>
+            <a:ext cx="161989" cy="0"/>
           </a:xfrm>
           <a:prstGeom prst="line">
             <a:avLst/>
@@ -7425,2053 +8818,862 @@
             <a:pPr>
               <a:defRPr/>
             </a:pPr>
-            <a:endParaRPr/>
-          </a:p>
-        </p:txBody>
-      </p:sp>
-      <p:sp>
-        <p:nvSpPr>
-          <p:cNvPr id="16" name=""/>
-          <p:cNvSpPr txBox="1"/>
-          <p:nvPr/>
-        </p:nvSpPr>
-        <p:spPr bwMode="auto">
-          <a:xfrm>
-            <a:off x="3995748" y="3175000"/>
-            <a:ext cx="434852" cy="305152"/>
-          </a:xfrm>
-          <a:prstGeom prst="rect">
-            <a:avLst/>
-          </a:prstGeom>
-          <a:noFill/>
-          <a:ln>
-            <a:noFill/>
-          </a:ln>
-          <a:effectLst/>
-        </p:spPr>
-        <p:txBody>
-          <a:bodyPr lIns="91440" tIns="45720" rIns="91440" bIns="45720" anchor="t">
-            <a:spAutoFit/>
-          </a:bodyPr>
-          <a:lstStyle/>
-          <a:p>
-            <a:pPr>
-              <a:defRPr/>
-            </a:pPr>
-            <a:r>
-              <a:rPr sz="1400"/>
-              <a:t>h</a:t>
-            </a:r>
-            <a:r>
-              <a:rPr sz="1400" baseline="-25000"/>
-              <a:t>0</a:t>
-            </a:r>
-            <a:endParaRPr/>
-          </a:p>
-        </p:txBody>
-      </p:sp>
-      <p:sp>
-        <p:nvSpPr>
-          <p:cNvPr id="17" name=""/>
-          <p:cNvSpPr txBox="1"/>
-          <p:nvPr/>
-        </p:nvSpPr>
-        <p:spPr bwMode="auto">
-          <a:xfrm>
-            <a:off x="6436394" y="3117763"/>
-            <a:ext cx="883024" cy="603321"/>
-          </a:xfrm>
-          <a:prstGeom prst="rect">
-            <a:avLst/>
-          </a:prstGeom>
-          <a:noFill/>
-          <a:ln w="12700">
-            <a:solidFill>
-              <a:srgbClr val="000000"/>
-            </a:solidFill>
-          </a:ln>
-          <a:effectLst/>
-        </p:spPr>
-        <p:txBody>
-          <a:bodyPr lIns="91440" tIns="45720" rIns="91440" bIns="45720" anchor="ctr"/>
-          <a:lstStyle/>
-          <a:p>
-            <a:pPr marL="0" algn="ctr">
-              <a:defRPr/>
-            </a:pPr>
-            <a:r>
-              <a:rPr sz="1400" strike="noStrike">
-                <a:latin typeface="Cantarell"/>
-                <a:cs typeface="Cantarell"/>
-              </a:rPr>
-              <a:t>RNN</a:t>
-            </a:r>
-            <a:endParaRPr/>
-          </a:p>
-        </p:txBody>
-      </p:sp>
-      <p:sp>
-        <p:nvSpPr>
-          <p:cNvPr id="18" name=""/>
-          <p:cNvSpPr/>
-          <p:nvPr/>
-        </p:nvSpPr>
-        <p:spPr bwMode="auto">
-          <a:xfrm flipV="1">
-            <a:off x="6537188" y="3768962"/>
-            <a:ext cx="0" cy="151190"/>
-          </a:xfrm>
-          <a:prstGeom prst="line">
-            <a:avLst/>
-          </a:prstGeom>
-          <a:ln w="12700">
-            <a:solidFill>
-              <a:srgbClr val="000000"/>
-            </a:solidFill>
-            <a:tailEnd type="triangle"/>
-          </a:ln>
-          <a:effectLst/>
-        </p:spPr>
-        <p:txBody>
-          <a:bodyPr/>
-          <a:lstStyle/>
-          <a:p>
-            <a:pPr>
-              <a:defRPr/>
-            </a:pPr>
-            <a:endParaRPr/>
-          </a:p>
-        </p:txBody>
-      </p:sp>
-      <p:sp>
-        <p:nvSpPr>
-          <p:cNvPr id="19" name=""/>
-          <p:cNvSpPr/>
-          <p:nvPr/>
-        </p:nvSpPr>
-        <p:spPr bwMode="auto">
-          <a:xfrm>
-            <a:off x="7318339" y="3419424"/>
-            <a:ext cx="341978" cy="0"/>
-          </a:xfrm>
-          <a:prstGeom prst="line">
-            <a:avLst/>
-          </a:prstGeom>
-          <a:ln w="12700">
-            <a:solidFill>
-              <a:srgbClr val="000000"/>
-            </a:solidFill>
-            <a:tailEnd type="triangle"/>
-          </a:ln>
-          <a:effectLst/>
-        </p:spPr>
-        <p:txBody>
-          <a:bodyPr/>
-          <a:lstStyle/>
-          <a:p>
-            <a:pPr>
-              <a:defRPr/>
-            </a:pPr>
-            <a:endParaRPr/>
-          </a:p>
-        </p:txBody>
-      </p:sp>
-      <p:sp>
-        <p:nvSpPr>
-          <p:cNvPr id="20" name=""/>
-          <p:cNvSpPr/>
-          <p:nvPr/>
-        </p:nvSpPr>
-        <p:spPr bwMode="auto">
-          <a:xfrm flipV="1">
-            <a:off x="6537188" y="2964413"/>
-            <a:ext cx="0" cy="151550"/>
-          </a:xfrm>
-          <a:prstGeom prst="line">
-            <a:avLst/>
-          </a:prstGeom>
-          <a:ln w="12700">
-            <a:solidFill>
-              <a:srgbClr val="000000"/>
-            </a:solidFill>
-            <a:tailEnd type="triangle"/>
-          </a:ln>
-          <a:effectLst/>
-        </p:spPr>
-        <p:txBody>
-          <a:bodyPr/>
-          <a:lstStyle/>
-          <a:p>
-            <a:pPr>
-              <a:defRPr/>
-            </a:pPr>
-            <a:endParaRPr/>
-          </a:p>
-        </p:txBody>
-      </p:sp>
-      <p:sp>
-        <p:nvSpPr>
-          <p:cNvPr id="21" name=""/>
-          <p:cNvSpPr/>
-          <p:nvPr/>
-        </p:nvSpPr>
-        <p:spPr bwMode="auto">
-          <a:xfrm flipV="1">
-            <a:off x="6875566" y="2964413"/>
-            <a:ext cx="0" cy="151550"/>
-          </a:xfrm>
-          <a:prstGeom prst="line">
-            <a:avLst/>
-          </a:prstGeom>
-          <a:ln w="12700">
-            <a:solidFill>
-              <a:srgbClr val="000000"/>
-            </a:solidFill>
-            <a:tailEnd type="triangle"/>
-          </a:ln>
-          <a:effectLst/>
-        </p:spPr>
-        <p:txBody>
-          <a:bodyPr/>
-          <a:lstStyle/>
-          <a:p>
-            <a:pPr>
-              <a:defRPr/>
-            </a:pPr>
-            <a:endParaRPr/>
-          </a:p>
-        </p:txBody>
-      </p:sp>
-      <p:sp>
-        <p:nvSpPr>
-          <p:cNvPr id="22" name=""/>
-          <p:cNvSpPr/>
-          <p:nvPr/>
-        </p:nvSpPr>
-        <p:spPr bwMode="auto">
-          <a:xfrm flipV="1">
-            <a:off x="7217545" y="2968732"/>
-            <a:ext cx="0" cy="151550"/>
-          </a:xfrm>
-          <a:prstGeom prst="line">
-            <a:avLst/>
-          </a:prstGeom>
-          <a:ln w="12700">
-            <a:solidFill>
-              <a:srgbClr val="000000"/>
-            </a:solidFill>
-            <a:tailEnd type="triangle"/>
-          </a:ln>
-          <a:effectLst/>
-        </p:spPr>
-        <p:txBody>
-          <a:bodyPr/>
-          <a:lstStyle/>
-          <a:p>
-            <a:pPr>
-              <a:defRPr/>
-            </a:pPr>
-            <a:endParaRPr/>
-          </a:p>
-        </p:txBody>
-      </p:sp>
-      <p:sp>
-        <p:nvSpPr>
-          <p:cNvPr id="23" name=""/>
-          <p:cNvSpPr/>
-          <p:nvPr/>
-        </p:nvSpPr>
-        <p:spPr bwMode="auto">
-          <a:xfrm flipV="1">
-            <a:off x="4802097" y="3783361"/>
-            <a:ext cx="0" cy="151190"/>
-          </a:xfrm>
-          <a:prstGeom prst="line">
-            <a:avLst/>
-          </a:prstGeom>
-          <a:ln w="12700">
-            <a:solidFill>
-              <a:srgbClr val="000000"/>
-            </a:solidFill>
-            <a:tailEnd type="triangle"/>
-          </a:ln>
-          <a:effectLst/>
-        </p:spPr>
-        <p:txBody>
-          <a:bodyPr/>
-          <a:lstStyle/>
-          <a:p>
-            <a:pPr>
-              <a:defRPr/>
-            </a:pPr>
-            <a:endParaRPr/>
-          </a:p>
-        </p:txBody>
-      </p:sp>
-      <p:sp>
-        <p:nvSpPr>
-          <p:cNvPr id="24" name=""/>
-          <p:cNvSpPr/>
-          <p:nvPr/>
-        </p:nvSpPr>
-        <p:spPr bwMode="auto">
-          <a:xfrm flipV="1">
-            <a:off x="5140476" y="3772562"/>
-            <a:ext cx="0" cy="151190"/>
-          </a:xfrm>
-          <a:prstGeom prst="line">
-            <a:avLst/>
-          </a:prstGeom>
-          <a:ln w="12700">
-            <a:solidFill>
-              <a:srgbClr val="000000"/>
-            </a:solidFill>
-            <a:tailEnd type="triangle"/>
-          </a:ln>
-          <a:effectLst/>
-        </p:spPr>
-        <p:txBody>
-          <a:bodyPr/>
-          <a:lstStyle/>
-          <a:p>
-            <a:pPr>
-              <a:defRPr/>
-            </a:pPr>
-            <a:endParaRPr/>
-          </a:p>
-        </p:txBody>
-      </p:sp>
-      <p:sp>
-        <p:nvSpPr>
-          <p:cNvPr id="25" name=""/>
-          <p:cNvSpPr/>
-          <p:nvPr/>
-        </p:nvSpPr>
-        <p:spPr bwMode="auto">
-          <a:xfrm flipV="1">
-            <a:off x="6875566" y="3768962"/>
-            <a:ext cx="0" cy="151190"/>
-          </a:xfrm>
-          <a:prstGeom prst="line">
-            <a:avLst/>
-          </a:prstGeom>
-          <a:ln w="12700">
-            <a:solidFill>
-              <a:srgbClr val="000000"/>
-            </a:solidFill>
-            <a:tailEnd type="triangle"/>
-          </a:ln>
-          <a:effectLst/>
-        </p:spPr>
-        <p:txBody>
-          <a:bodyPr/>
-          <a:lstStyle/>
-          <a:p>
-            <a:pPr>
-              <a:defRPr/>
-            </a:pPr>
-            <a:endParaRPr/>
-          </a:p>
-        </p:txBody>
-      </p:sp>
-      <p:sp>
-        <p:nvSpPr>
-          <p:cNvPr id="26" name=""/>
-          <p:cNvSpPr/>
-          <p:nvPr/>
-        </p:nvSpPr>
-        <p:spPr bwMode="auto">
-          <a:xfrm flipV="1">
-            <a:off x="7217545" y="3772562"/>
-            <a:ext cx="0" cy="151190"/>
-          </a:xfrm>
-          <a:prstGeom prst="line">
-            <a:avLst/>
-          </a:prstGeom>
-          <a:ln w="12700">
-            <a:solidFill>
-              <a:srgbClr val="000000"/>
-            </a:solidFill>
-            <a:tailEnd type="triangle"/>
-          </a:ln>
-          <a:effectLst/>
-        </p:spPr>
-        <p:txBody>
-          <a:bodyPr/>
-          <a:lstStyle/>
-          <a:p>
-            <a:pPr>
-              <a:defRPr/>
-            </a:pPr>
-            <a:endParaRPr/>
-          </a:p>
-        </p:txBody>
-      </p:sp>
-      <p:sp>
-        <p:nvSpPr>
-          <p:cNvPr id="27" name=""/>
-          <p:cNvSpPr/>
-          <p:nvPr/>
-        </p:nvSpPr>
-        <p:spPr bwMode="auto">
-          <a:xfrm>
-            <a:off x="5799234" y="4074943"/>
-            <a:ext cx="475170" cy="0"/>
-          </a:xfrm>
-          <a:prstGeom prst="line">
-            <a:avLst/>
-          </a:prstGeom>
-          <a:ln w="19050">
-            <a:solidFill>
-              <a:srgbClr val="205967"/>
-            </a:solidFill>
-            <a:tailEnd type="triangle"/>
-          </a:ln>
-          <a:effectLst/>
-        </p:spPr>
-        <p:txBody>
-          <a:bodyPr/>
-          <a:lstStyle/>
-          <a:p>
-            <a:pPr>
-              <a:defRPr/>
-            </a:pPr>
-            <a:endParaRPr/>
-          </a:p>
-        </p:txBody>
-      </p:sp>
-      <p:sp>
-        <p:nvSpPr>
-          <p:cNvPr id="28" name=""/>
-          <p:cNvSpPr/>
-          <p:nvPr/>
-        </p:nvSpPr>
-        <p:spPr bwMode="auto">
-          <a:xfrm>
-            <a:off x="5424857" y="2860738"/>
-            <a:ext cx="392375" cy="0"/>
-          </a:xfrm>
-          <a:prstGeom prst="line">
-            <a:avLst/>
-          </a:prstGeom>
-          <a:ln w="19050">
-            <a:solidFill>
-              <a:srgbClr val="205967"/>
-            </a:solidFill>
-          </a:ln>
-          <a:effectLst/>
-        </p:spPr>
-        <p:txBody>
-          <a:bodyPr/>
-          <a:lstStyle/>
-          <a:p>
-            <a:pPr>
-              <a:defRPr/>
-            </a:pPr>
-            <a:endParaRPr/>
-          </a:p>
-        </p:txBody>
-      </p:sp>
-      <p:sp>
-        <p:nvSpPr>
-          <p:cNvPr id="29" name=""/>
-          <p:cNvSpPr/>
-          <p:nvPr/>
-        </p:nvSpPr>
-        <p:spPr bwMode="auto">
-          <a:xfrm>
-            <a:off x="5817233" y="2863619"/>
-            <a:ext cx="0" cy="1207723"/>
-          </a:xfrm>
-          <a:prstGeom prst="line">
-            <a:avLst/>
-          </a:prstGeom>
-          <a:ln w="19050">
-            <a:solidFill>
-              <a:srgbClr val="205967"/>
-            </a:solidFill>
-          </a:ln>
-          <a:effectLst/>
-        </p:spPr>
-        <p:txBody>
-          <a:bodyPr/>
-          <a:lstStyle/>
-          <a:p>
-            <a:pPr>
-              <a:defRPr/>
-            </a:pPr>
-            <a:endParaRPr/>
-          </a:p>
-        </p:txBody>
-      </p:sp>
-      <p:sp>
-        <p:nvSpPr>
-          <p:cNvPr id="30" name=""/>
-          <p:cNvSpPr txBox="1"/>
-          <p:nvPr/>
-        </p:nvSpPr>
-        <p:spPr bwMode="auto">
-          <a:xfrm>
-            <a:off x="5774036" y="3244475"/>
-            <a:ext cx="435932" cy="335642"/>
-          </a:xfrm>
-          <a:prstGeom prst="rect">
-            <a:avLst/>
-          </a:prstGeom>
-          <a:noFill/>
-          <a:ln>
-            <a:noFill/>
-          </a:ln>
-          <a:effectLst/>
-        </p:spPr>
-        <p:txBody>
-          <a:bodyPr lIns="91440" tIns="45720" rIns="91440" bIns="45720" anchor="t">
-            <a:spAutoFit/>
-          </a:bodyPr>
-          <a:lstStyle/>
-          <a:p>
-            <a:pPr>
-              <a:defRPr/>
-            </a:pPr>
-            <a:r>
-              <a:rPr sz="1600"/>
-              <a:t>m</a:t>
-            </a:r>
-            <a:endParaRPr/>
-          </a:p>
-        </p:txBody>
-      </p:sp>
-      <p:sp>
-        <p:nvSpPr>
-          <p:cNvPr id="31" name=""/>
-          <p:cNvSpPr txBox="1"/>
-          <p:nvPr/>
-        </p:nvSpPr>
-        <p:spPr bwMode="auto">
-          <a:xfrm>
-            <a:off x="7307539" y="3163840"/>
-            <a:ext cx="435932" cy="305152"/>
-          </a:xfrm>
-          <a:prstGeom prst="rect">
-            <a:avLst/>
-          </a:prstGeom>
-          <a:noFill/>
-          <a:ln>
-            <a:noFill/>
-          </a:ln>
-          <a:effectLst/>
-        </p:spPr>
-        <p:txBody>
-          <a:bodyPr lIns="91440" tIns="45720" rIns="91440" bIns="45720" anchor="t">
-            <a:spAutoFit/>
-          </a:bodyPr>
-          <a:lstStyle/>
-          <a:p>
-            <a:pPr>
-              <a:defRPr/>
-            </a:pPr>
-            <a:r>
-              <a:rPr sz="1400"/>
-              <a:t>h</a:t>
-            </a:r>
-            <a:r>
-              <a:rPr sz="1400" baseline="-25000"/>
-              <a:t>n</a:t>
-            </a:r>
-            <a:endParaRPr/>
-          </a:p>
-        </p:txBody>
-      </p:sp>
-      <p:sp>
-        <p:nvSpPr>
-          <p:cNvPr id="32" name=""/>
-          <p:cNvSpPr txBox="1"/>
-          <p:nvPr/>
-        </p:nvSpPr>
-        <p:spPr bwMode="auto">
-          <a:xfrm>
-            <a:off x="4899291" y="1895640"/>
-            <a:ext cx="1852443" cy="335642"/>
-          </a:xfrm>
-          <a:prstGeom prst="rect">
-            <a:avLst/>
-          </a:prstGeom>
-          <a:noFill/>
-          <a:ln>
-            <a:noFill/>
-          </a:ln>
-          <a:effectLst/>
-        </p:spPr>
-        <p:txBody>
-          <a:bodyPr lIns="91440" tIns="45720" rIns="91440" bIns="45720" anchor="t">
-            <a:spAutoFit/>
-          </a:bodyPr>
-          <a:lstStyle/>
-          <a:p>
-            <a:pPr algn="ctr">
-              <a:defRPr/>
-            </a:pPr>
-            <a:r>
-              <a:rPr sz="1600" b="1"/>
-              <a:t>INPUT</a:t>
-            </a:r>
-            <a:endParaRPr/>
-          </a:p>
-        </p:txBody>
-      </p:sp>
-      <p:sp>
-        <p:nvSpPr>
-          <p:cNvPr id="33" name=""/>
-          <p:cNvSpPr txBox="1"/>
-          <p:nvPr/>
-        </p:nvSpPr>
-        <p:spPr bwMode="auto">
-          <a:xfrm>
-            <a:off x="5054081" y="4571712"/>
-            <a:ext cx="1543222" cy="579563"/>
-          </a:xfrm>
-          <a:prstGeom prst="rect">
-            <a:avLst/>
-          </a:prstGeom>
-          <a:noFill/>
-          <a:ln>
-            <a:noFill/>
-          </a:ln>
-          <a:effectLst/>
-        </p:spPr>
-        <p:txBody>
-          <a:bodyPr lIns="91440" tIns="45720" rIns="91440" bIns="45720" anchor="t">
-            <a:spAutoFit/>
-          </a:bodyPr>
-          <a:lstStyle/>
-          <a:p>
-            <a:pPr algn="ctr">
-              <a:defRPr/>
-            </a:pPr>
-            <a:r>
-              <a:rPr sz="1600" b="1"/>
-              <a:t>GROUND TRUTH</a:t>
-            </a:r>
-            <a:endParaRPr/>
-          </a:p>
-        </p:txBody>
-      </p:sp>
-      <p:sp>
-        <p:nvSpPr>
-          <p:cNvPr id="34" name=""/>
-          <p:cNvSpPr/>
-          <p:nvPr/>
-        </p:nvSpPr>
-        <p:spPr bwMode="auto">
-          <a:xfrm>
-            <a:off x="2988891" y="3173200"/>
-            <a:ext cx="214294" cy="214294"/>
-          </a:xfrm>
-          <a:prstGeom prst="ellipse">
-            <a:avLst/>
-          </a:prstGeom>
-          <a:noFill/>
-          <a:ln w="12700">
-            <a:solidFill>
-              <a:srgbClr val="000000"/>
-            </a:solidFill>
-          </a:ln>
-          <a:effectLst/>
-        </p:spPr>
-        <p:txBody>
-          <a:bodyPr/>
-          <a:lstStyle/>
-          <a:p>
-            <a:pPr>
-              <a:defRPr/>
-            </a:pPr>
-            <a:endParaRPr/>
-          </a:p>
-        </p:txBody>
-      </p:sp>
-      <p:sp>
-        <p:nvSpPr>
-          <p:cNvPr id="35" name=""/>
-          <p:cNvSpPr/>
-          <p:nvPr/>
-        </p:nvSpPr>
-        <p:spPr bwMode="auto">
-          <a:xfrm>
-            <a:off x="2988891" y="3509058"/>
-            <a:ext cx="214294" cy="214294"/>
-          </a:xfrm>
-          <a:prstGeom prst="ellipse">
-            <a:avLst/>
-          </a:prstGeom>
-          <a:noFill/>
-          <a:ln w="12700">
-            <a:solidFill>
-              <a:srgbClr val="000000"/>
-            </a:solidFill>
-          </a:ln>
-          <a:effectLst/>
-        </p:spPr>
-        <p:txBody>
-          <a:bodyPr/>
-          <a:lstStyle/>
-          <a:p>
-            <a:pPr>
-              <a:defRPr/>
-            </a:pPr>
-            <a:endParaRPr/>
-          </a:p>
-        </p:txBody>
-      </p:sp>
-      <p:sp>
-        <p:nvSpPr>
-          <p:cNvPr id="36" name=""/>
-          <p:cNvSpPr/>
-          <p:nvPr/>
-        </p:nvSpPr>
-        <p:spPr bwMode="auto">
-          <a:xfrm>
-            <a:off x="3277593" y="3340229"/>
-            <a:ext cx="214294" cy="214294"/>
-          </a:xfrm>
-          <a:prstGeom prst="ellipse">
-            <a:avLst/>
-          </a:prstGeom>
-          <a:noFill/>
-          <a:ln w="12700">
-            <a:solidFill>
-              <a:srgbClr val="000000"/>
-            </a:solidFill>
-          </a:ln>
-          <a:effectLst/>
-        </p:spPr>
-        <p:txBody>
-          <a:bodyPr/>
-          <a:lstStyle/>
-          <a:p>
-            <a:pPr>
-              <a:defRPr/>
-            </a:pPr>
-            <a:endParaRPr/>
-          </a:p>
-        </p:txBody>
-      </p:sp>
-      <p:sp>
-        <p:nvSpPr>
-          <p:cNvPr id="37" name=""/>
-          <p:cNvSpPr/>
-          <p:nvPr/>
-        </p:nvSpPr>
-        <p:spPr bwMode="auto">
-          <a:xfrm>
-            <a:off x="3277593" y="3024169"/>
-            <a:ext cx="214294" cy="214294"/>
-          </a:xfrm>
-          <a:prstGeom prst="ellipse">
-            <a:avLst/>
-          </a:prstGeom>
-          <a:noFill/>
-          <a:ln w="12700">
-            <a:solidFill>
-              <a:srgbClr val="000000"/>
-            </a:solidFill>
-          </a:ln>
-          <a:effectLst/>
-        </p:spPr>
-        <p:txBody>
-          <a:bodyPr/>
-          <a:lstStyle/>
-          <a:p>
-            <a:pPr>
-              <a:defRPr/>
-            </a:pPr>
-            <a:endParaRPr/>
-          </a:p>
-        </p:txBody>
-      </p:sp>
-      <p:sp>
-        <p:nvSpPr>
-          <p:cNvPr id="38" name=""/>
-          <p:cNvSpPr/>
-          <p:nvPr/>
-        </p:nvSpPr>
-        <p:spPr bwMode="auto">
-          <a:xfrm>
-            <a:off x="3277593" y="3642970"/>
-            <a:ext cx="214294" cy="214294"/>
-          </a:xfrm>
-          <a:prstGeom prst="ellipse">
-            <a:avLst/>
-          </a:prstGeom>
-          <a:noFill/>
-          <a:ln w="12700">
-            <a:solidFill>
-              <a:srgbClr val="000000"/>
-            </a:solidFill>
-          </a:ln>
-          <a:effectLst/>
-        </p:spPr>
-        <p:txBody>
-          <a:bodyPr/>
-          <a:lstStyle/>
-          <a:p>
-            <a:pPr>
-              <a:defRPr/>
-            </a:pPr>
-            <a:endParaRPr/>
-          </a:p>
-        </p:txBody>
-      </p:sp>
-      <p:sp>
-        <p:nvSpPr>
-          <p:cNvPr id="39" name=""/>
-          <p:cNvSpPr/>
-          <p:nvPr/>
-        </p:nvSpPr>
-        <p:spPr bwMode="auto">
-          <a:xfrm>
-            <a:off x="3582854" y="3332670"/>
-            <a:ext cx="214294" cy="214294"/>
-          </a:xfrm>
-          <a:prstGeom prst="ellipse">
-            <a:avLst/>
-          </a:prstGeom>
-          <a:noFill/>
-          <a:ln w="12700">
-            <a:solidFill>
-              <a:srgbClr val="000000"/>
-            </a:solidFill>
-          </a:ln>
-          <a:effectLst/>
-        </p:spPr>
-        <p:txBody>
-          <a:bodyPr/>
-          <a:lstStyle/>
-          <a:p>
-            <a:pPr>
-              <a:defRPr/>
-            </a:pPr>
-            <a:endParaRPr/>
-          </a:p>
-        </p:txBody>
-      </p:sp>
-      <p:sp>
-        <p:nvSpPr>
-          <p:cNvPr id="40" name=""/>
-          <p:cNvSpPr/>
-          <p:nvPr/>
-        </p:nvSpPr>
-        <p:spPr bwMode="auto">
-          <a:xfrm flipH="1">
-            <a:off x="20201" y="1575620"/>
-            <a:ext cx="16335" cy="44996"/>
-          </a:xfrm>
-          <a:prstGeom prst="line">
-            <a:avLst/>
-          </a:prstGeom>
-          <a:ln w="12700">
-            <a:solidFill>
-              <a:srgbClr val="000000"/>
-            </a:solidFill>
-          </a:ln>
-          <a:effectLst/>
-        </p:spPr>
-        <p:txBody>
-          <a:bodyPr/>
-          <a:lstStyle/>
-          <a:p>
-            <a:pPr>
-              <a:defRPr/>
-            </a:pPr>
-            <a:endParaRPr/>
-          </a:p>
-        </p:txBody>
-      </p:sp>
-      <p:sp>
-        <p:nvSpPr>
-          <p:cNvPr id="41" name=""/>
-          <p:cNvSpPr/>
-          <p:nvPr/>
-        </p:nvSpPr>
-        <p:spPr bwMode="auto">
-          <a:xfrm flipH="1">
-            <a:off x="-137834" y="1654815"/>
-            <a:ext cx="6407" cy="49676"/>
-          </a:xfrm>
-          <a:prstGeom prst="line">
-            <a:avLst/>
-          </a:prstGeom>
-          <a:ln w="12700">
-            <a:solidFill>
-              <a:srgbClr val="000000"/>
-            </a:solidFill>
-          </a:ln>
-          <a:effectLst/>
-        </p:spPr>
-        <p:txBody>
-          <a:bodyPr/>
-          <a:lstStyle/>
-          <a:p>
-            <a:pPr>
-              <a:defRPr/>
-            </a:pPr>
-            <a:endParaRPr/>
-          </a:p>
-        </p:txBody>
-      </p:sp>
-      <p:sp>
-        <p:nvSpPr>
-          <p:cNvPr id="42" name=""/>
-          <p:cNvSpPr/>
-          <p:nvPr/>
-        </p:nvSpPr>
-        <p:spPr bwMode="auto">
-          <a:xfrm flipV="1">
-            <a:off x="3263914" y="38769"/>
-            <a:ext cx="91074" cy="7307"/>
-          </a:xfrm>
-          <a:prstGeom prst="line">
-            <a:avLst/>
-          </a:prstGeom>
-          <a:ln w="12700">
-            <a:solidFill>
-              <a:srgbClr val="000000"/>
-            </a:solidFill>
-          </a:ln>
-          <a:effectLst/>
-        </p:spPr>
-        <p:txBody>
-          <a:bodyPr/>
-          <a:lstStyle/>
-          <a:p>
-            <a:pPr>
-              <a:defRPr/>
-            </a:pPr>
-            <a:endParaRPr/>
-          </a:p>
-        </p:txBody>
-      </p:sp>
-      <p:sp>
-        <p:nvSpPr>
-          <p:cNvPr id="43" name=""/>
-          <p:cNvSpPr/>
-          <p:nvPr/>
-        </p:nvSpPr>
-        <p:spPr bwMode="auto">
-          <a:xfrm>
-            <a:off x="3263914" y="46077"/>
-            <a:ext cx="226785" cy="44852"/>
-          </a:xfrm>
-          <a:prstGeom prst="line">
-            <a:avLst/>
-          </a:prstGeom>
-          <a:ln w="12700">
-            <a:solidFill>
-              <a:srgbClr val="000000"/>
-            </a:solidFill>
-          </a:ln>
-          <a:effectLst/>
-        </p:spPr>
-        <p:txBody>
-          <a:bodyPr/>
-          <a:lstStyle/>
-          <a:p>
-            <a:pPr>
-              <a:defRPr/>
-            </a:pPr>
-            <a:endParaRPr/>
-          </a:p>
-        </p:txBody>
-      </p:sp>
-      <p:sp>
-        <p:nvSpPr>
-          <p:cNvPr id="44" name=""/>
-          <p:cNvSpPr/>
-          <p:nvPr/>
-        </p:nvSpPr>
-        <p:spPr bwMode="auto">
-          <a:xfrm>
-            <a:off x="3171760" y="3693367"/>
-            <a:ext cx="105833" cy="53996"/>
-          </a:xfrm>
-          <a:prstGeom prst="line">
-            <a:avLst/>
-          </a:prstGeom>
-          <a:ln w="12700">
-            <a:solidFill>
-              <a:srgbClr val="000000"/>
-            </a:solidFill>
-          </a:ln>
-          <a:effectLst/>
-        </p:spPr>
-        <p:txBody>
-          <a:bodyPr/>
-          <a:lstStyle/>
-          <a:p>
-            <a:pPr>
-              <a:defRPr/>
-            </a:pPr>
-            <a:endParaRPr/>
-          </a:p>
-        </p:txBody>
-      </p:sp>
-      <p:sp>
-        <p:nvSpPr>
-          <p:cNvPr id="45" name=""/>
-          <p:cNvSpPr/>
-          <p:nvPr/>
-        </p:nvSpPr>
-        <p:spPr bwMode="auto">
-          <a:xfrm>
-            <a:off x="-115731" y="1594699"/>
-            <a:ext cx="98047" cy="117712"/>
-          </a:xfrm>
-          <a:prstGeom prst="line">
-            <a:avLst/>
-          </a:prstGeom>
-          <a:ln w="12700">
-            <a:solidFill>
-              <a:srgbClr val="000000"/>
-            </a:solidFill>
-          </a:ln>
-          <a:effectLst/>
-        </p:spPr>
-        <p:txBody>
-          <a:bodyPr/>
-          <a:lstStyle/>
-          <a:p>
-            <a:pPr>
-              <a:defRPr/>
-            </a:pPr>
-            <a:endParaRPr/>
-          </a:p>
-        </p:txBody>
-      </p:sp>
-      <p:sp>
-        <p:nvSpPr>
-          <p:cNvPr id="46" name=""/>
-          <p:cNvSpPr/>
-          <p:nvPr/>
-        </p:nvSpPr>
-        <p:spPr bwMode="auto">
-          <a:xfrm>
-            <a:off x="3333750" y="-63355"/>
-            <a:ext cx="155510" cy="863"/>
-          </a:xfrm>
-          <a:prstGeom prst="line">
-            <a:avLst/>
-          </a:prstGeom>
-          <a:ln w="12700">
-            <a:solidFill>
-              <a:srgbClr val="000000"/>
-            </a:solidFill>
-          </a:ln>
-          <a:effectLst/>
-        </p:spPr>
-        <p:txBody>
-          <a:bodyPr/>
-          <a:lstStyle/>
-          <a:p>
-            <a:pPr>
-              <a:defRPr/>
-            </a:pPr>
-            <a:endParaRPr/>
-          </a:p>
-        </p:txBody>
-      </p:sp>
-      <p:sp>
-        <p:nvSpPr>
-          <p:cNvPr id="47" name=""/>
-          <p:cNvSpPr/>
-          <p:nvPr/>
-        </p:nvSpPr>
-        <p:spPr bwMode="auto">
-          <a:xfrm>
-            <a:off x="-29236" y="1744090"/>
-            <a:ext cx="1616" cy="77755"/>
-          </a:xfrm>
-          <a:prstGeom prst="line">
-            <a:avLst/>
-          </a:prstGeom>
-          <a:ln w="12700">
-            <a:solidFill>
-              <a:srgbClr val="000000"/>
-            </a:solidFill>
-          </a:ln>
-          <a:effectLst/>
-        </p:spPr>
-        <p:txBody>
-          <a:bodyPr/>
-          <a:lstStyle/>
-          <a:p>
-            <a:pPr>
-              <a:defRPr/>
-            </a:pPr>
-            <a:endParaRPr/>
-          </a:p>
-        </p:txBody>
-      </p:sp>
-      <p:sp>
-        <p:nvSpPr>
-          <p:cNvPr id="48" name=""/>
-          <p:cNvSpPr/>
-          <p:nvPr/>
-        </p:nvSpPr>
-        <p:spPr bwMode="auto">
-          <a:xfrm>
-            <a:off x="3491780" y="3443543"/>
-            <a:ext cx="91074" cy="0"/>
-          </a:xfrm>
-          <a:prstGeom prst="line">
-            <a:avLst/>
-          </a:prstGeom>
-          <a:ln w="12700">
-            <a:solidFill>
-              <a:srgbClr val="000000"/>
-            </a:solidFill>
-          </a:ln>
-          <a:effectLst/>
-        </p:spPr>
-        <p:txBody>
-          <a:bodyPr/>
-          <a:lstStyle/>
-          <a:p>
-            <a:pPr>
-              <a:defRPr/>
-            </a:pPr>
-            <a:endParaRPr/>
-          </a:p>
-        </p:txBody>
-      </p:sp>
-      <p:sp>
-        <p:nvSpPr>
-          <p:cNvPr id="49" name=""/>
-          <p:cNvSpPr/>
-          <p:nvPr/>
-        </p:nvSpPr>
-        <p:spPr bwMode="auto">
-          <a:xfrm>
-            <a:off x="7779109" y="3153761"/>
-            <a:ext cx="214294" cy="214294"/>
-          </a:xfrm>
-          <a:prstGeom prst="ellipse">
-            <a:avLst/>
-          </a:prstGeom>
-          <a:noFill/>
-          <a:ln w="12700">
-            <a:solidFill>
-              <a:srgbClr val="000000"/>
-            </a:solidFill>
-          </a:ln>
-          <a:effectLst/>
-        </p:spPr>
-        <p:txBody>
-          <a:bodyPr/>
-          <a:lstStyle/>
-          <a:p>
-            <a:pPr>
-              <a:defRPr/>
-            </a:pPr>
-            <a:endParaRPr/>
-          </a:p>
-        </p:txBody>
-      </p:sp>
-      <p:sp>
-        <p:nvSpPr>
-          <p:cNvPr id="50" name=""/>
-          <p:cNvSpPr/>
-          <p:nvPr/>
-        </p:nvSpPr>
-        <p:spPr bwMode="auto">
-          <a:xfrm>
-            <a:off x="7779109" y="3489620"/>
-            <a:ext cx="214294" cy="214294"/>
-          </a:xfrm>
-          <a:prstGeom prst="ellipse">
-            <a:avLst/>
-          </a:prstGeom>
-          <a:noFill/>
-          <a:ln w="12700">
-            <a:solidFill>
-              <a:srgbClr val="000000"/>
-            </a:solidFill>
-          </a:ln>
-          <a:effectLst/>
-        </p:spPr>
-        <p:txBody>
-          <a:bodyPr/>
-          <a:lstStyle/>
-          <a:p>
-            <a:pPr>
-              <a:defRPr/>
-            </a:pPr>
-            <a:endParaRPr/>
-          </a:p>
-        </p:txBody>
-      </p:sp>
-      <p:sp>
-        <p:nvSpPr>
-          <p:cNvPr id="51" name=""/>
-          <p:cNvSpPr/>
-          <p:nvPr/>
-        </p:nvSpPr>
-        <p:spPr bwMode="auto">
-          <a:xfrm>
-            <a:off x="8067091" y="3320790"/>
-            <a:ext cx="214294" cy="214294"/>
-          </a:xfrm>
-          <a:prstGeom prst="ellipse">
-            <a:avLst/>
-          </a:prstGeom>
-          <a:noFill/>
-          <a:ln w="12700">
-            <a:solidFill>
-              <a:srgbClr val="000000"/>
-            </a:solidFill>
-          </a:ln>
-          <a:effectLst/>
-        </p:spPr>
-        <p:txBody>
-          <a:bodyPr/>
-          <a:lstStyle/>
-          <a:p>
-            <a:pPr>
-              <a:defRPr/>
-            </a:pPr>
-            <a:endParaRPr/>
-          </a:p>
-        </p:txBody>
-      </p:sp>
-      <p:sp>
-        <p:nvSpPr>
-          <p:cNvPr id="52" name=""/>
-          <p:cNvSpPr/>
-          <p:nvPr/>
-        </p:nvSpPr>
-        <p:spPr bwMode="auto">
-          <a:xfrm>
-            <a:off x="8067091" y="3004730"/>
-            <a:ext cx="214294" cy="214294"/>
-          </a:xfrm>
-          <a:prstGeom prst="ellipse">
-            <a:avLst/>
-          </a:prstGeom>
-          <a:noFill/>
-          <a:ln w="12700">
-            <a:solidFill>
-              <a:srgbClr val="000000"/>
-            </a:solidFill>
-          </a:ln>
-          <a:effectLst/>
-        </p:spPr>
-        <p:txBody>
-          <a:bodyPr/>
-          <a:lstStyle/>
-          <a:p>
-            <a:pPr>
-              <a:defRPr/>
-            </a:pPr>
-            <a:endParaRPr/>
-          </a:p>
-        </p:txBody>
-      </p:sp>
-      <p:sp>
-        <p:nvSpPr>
-          <p:cNvPr id="53" name=""/>
-          <p:cNvSpPr/>
-          <p:nvPr/>
-        </p:nvSpPr>
-        <p:spPr bwMode="auto">
-          <a:xfrm>
-            <a:off x="8067091" y="3621371"/>
-            <a:ext cx="214294" cy="214294"/>
-          </a:xfrm>
-          <a:prstGeom prst="ellipse">
-            <a:avLst/>
-          </a:prstGeom>
-          <a:noFill/>
-          <a:ln w="12700">
-            <a:solidFill>
-              <a:srgbClr val="000000"/>
-            </a:solidFill>
-          </a:ln>
-          <a:effectLst/>
-        </p:spPr>
-        <p:txBody>
-          <a:bodyPr/>
-          <a:lstStyle/>
-          <a:p>
-            <a:pPr>
-              <a:defRPr/>
-            </a:pPr>
-            <a:endParaRPr/>
-          </a:p>
-        </p:txBody>
-      </p:sp>
-      <p:sp>
-        <p:nvSpPr>
-          <p:cNvPr id="54" name=""/>
-          <p:cNvSpPr/>
-          <p:nvPr/>
-        </p:nvSpPr>
-        <p:spPr bwMode="auto">
-          <a:xfrm>
-            <a:off x="8373072" y="3313591"/>
-            <a:ext cx="214294" cy="214294"/>
-          </a:xfrm>
-          <a:prstGeom prst="ellipse">
-            <a:avLst/>
-          </a:prstGeom>
-          <a:noFill/>
-          <a:ln w="12700">
-            <a:solidFill>
-              <a:srgbClr val="000000"/>
-            </a:solidFill>
-          </a:ln>
-          <a:effectLst/>
-        </p:spPr>
-        <p:txBody>
-          <a:bodyPr/>
-          <a:lstStyle/>
-          <a:p>
-            <a:pPr>
-              <a:defRPr/>
-            </a:pPr>
-            <a:endParaRPr/>
-          </a:p>
-        </p:txBody>
-      </p:sp>
-      <p:sp>
-        <p:nvSpPr>
-          <p:cNvPr id="55" name=""/>
-          <p:cNvSpPr/>
-          <p:nvPr/>
-        </p:nvSpPr>
-        <p:spPr bwMode="auto">
-          <a:xfrm flipH="1">
-            <a:off x="2424807" y="2768585"/>
-            <a:ext cx="16198" cy="44636"/>
-          </a:xfrm>
-          <a:prstGeom prst="line">
-            <a:avLst/>
-          </a:prstGeom>
-          <a:ln w="12700">
-            <a:solidFill>
-              <a:srgbClr val="000000"/>
-            </a:solidFill>
-          </a:ln>
-          <a:effectLst/>
-        </p:spPr>
-        <p:txBody>
-          <a:bodyPr/>
-          <a:lstStyle/>
-          <a:p>
-            <a:pPr>
-              <a:defRPr/>
-            </a:pPr>
-            <a:endParaRPr/>
-          </a:p>
-        </p:txBody>
-      </p:sp>
-      <p:sp>
-        <p:nvSpPr>
-          <p:cNvPr id="56" name=""/>
-          <p:cNvSpPr/>
-          <p:nvPr/>
-        </p:nvSpPr>
-        <p:spPr bwMode="auto">
-          <a:xfrm flipH="1">
-            <a:off x="2266777" y="2847420"/>
-            <a:ext cx="6479" cy="49676"/>
-          </a:xfrm>
-          <a:prstGeom prst="line">
-            <a:avLst/>
-          </a:prstGeom>
-          <a:ln w="12700">
-            <a:solidFill>
-              <a:srgbClr val="000000"/>
-            </a:solidFill>
-          </a:ln>
-          <a:effectLst/>
-        </p:spPr>
-        <p:txBody>
-          <a:bodyPr/>
-          <a:lstStyle/>
-          <a:p>
-            <a:pPr>
-              <a:defRPr/>
-            </a:pPr>
-            <a:endParaRPr/>
-          </a:p>
-        </p:txBody>
-      </p:sp>
-      <p:sp>
-        <p:nvSpPr>
-          <p:cNvPr id="57" name=""/>
-          <p:cNvSpPr/>
-          <p:nvPr/>
-        </p:nvSpPr>
-        <p:spPr bwMode="auto">
-          <a:xfrm flipV="1">
-            <a:off x="5648044" y="-1163445"/>
-            <a:ext cx="93594" cy="7199"/>
-          </a:xfrm>
-          <a:prstGeom prst="line">
-            <a:avLst/>
-          </a:prstGeom>
-          <a:ln w="12700">
-            <a:solidFill>
-              <a:srgbClr val="000000"/>
-            </a:solidFill>
-          </a:ln>
-          <a:effectLst/>
-        </p:spPr>
-        <p:txBody>
-          <a:bodyPr/>
-          <a:lstStyle/>
-          <a:p>
-            <a:pPr>
-              <a:defRPr/>
-            </a:pPr>
-            <a:endParaRPr/>
-          </a:p>
-        </p:txBody>
-      </p:sp>
-      <p:sp>
-        <p:nvSpPr>
-          <p:cNvPr id="58" name=""/>
-          <p:cNvSpPr/>
-          <p:nvPr/>
-        </p:nvSpPr>
-        <p:spPr bwMode="auto">
-          <a:xfrm>
-            <a:off x="5648044" y="-1156246"/>
-            <a:ext cx="226785" cy="44996"/>
-          </a:xfrm>
-          <a:prstGeom prst="line">
-            <a:avLst/>
-          </a:prstGeom>
-          <a:ln w="12700">
-            <a:solidFill>
-              <a:srgbClr val="000000"/>
-            </a:solidFill>
-          </a:ln>
-          <a:effectLst/>
-        </p:spPr>
-        <p:txBody>
-          <a:bodyPr/>
-          <a:lstStyle/>
-          <a:p>
-            <a:pPr>
-              <a:defRPr/>
-            </a:pPr>
-            <a:endParaRPr/>
-          </a:p>
-        </p:txBody>
-      </p:sp>
-      <p:sp>
-        <p:nvSpPr>
-          <p:cNvPr id="59" name=""/>
-          <p:cNvSpPr/>
-          <p:nvPr/>
-        </p:nvSpPr>
-        <p:spPr bwMode="auto">
-          <a:xfrm>
-            <a:off x="7962698" y="3671768"/>
-            <a:ext cx="104393" cy="57596"/>
-          </a:xfrm>
-          <a:prstGeom prst="line">
-            <a:avLst/>
-          </a:prstGeom>
-          <a:ln w="12700">
-            <a:solidFill>
-              <a:srgbClr val="000000"/>
-            </a:solidFill>
-          </a:ln>
-          <a:effectLst/>
-        </p:spPr>
-        <p:txBody>
-          <a:bodyPr/>
-          <a:lstStyle/>
-          <a:p>
-            <a:pPr>
-              <a:defRPr/>
-            </a:pPr>
-            <a:endParaRPr/>
-          </a:p>
-        </p:txBody>
-      </p:sp>
-      <p:sp>
-        <p:nvSpPr>
-          <p:cNvPr id="60" name=""/>
-          <p:cNvSpPr/>
-          <p:nvPr/>
-        </p:nvSpPr>
-        <p:spPr bwMode="auto">
-          <a:xfrm>
-            <a:off x="2288735" y="2787304"/>
-            <a:ext cx="98273" cy="117712"/>
-          </a:xfrm>
-          <a:prstGeom prst="line">
-            <a:avLst/>
-          </a:prstGeom>
-          <a:ln w="12700">
-            <a:solidFill>
-              <a:srgbClr val="000000"/>
-            </a:solidFill>
-          </a:ln>
-          <a:effectLst/>
-        </p:spPr>
-        <p:txBody>
-          <a:bodyPr/>
-          <a:lstStyle/>
-          <a:p>
-            <a:pPr>
-              <a:defRPr/>
-            </a:pPr>
-            <a:endParaRPr/>
-          </a:p>
-        </p:txBody>
-      </p:sp>
-      <p:sp>
-        <p:nvSpPr>
-          <p:cNvPr id="61" name=""/>
-          <p:cNvSpPr/>
-          <p:nvPr/>
-        </p:nvSpPr>
-        <p:spPr bwMode="auto">
-          <a:xfrm>
-            <a:off x="5720039" y="-1265679"/>
-            <a:ext cx="154790" cy="1079"/>
-          </a:xfrm>
-          <a:prstGeom prst="line">
-            <a:avLst/>
-          </a:prstGeom>
-          <a:ln w="12700">
-            <a:solidFill>
-              <a:srgbClr val="000000"/>
-            </a:solidFill>
-          </a:ln>
-          <a:effectLst/>
-        </p:spPr>
-        <p:txBody>
-          <a:bodyPr/>
-          <a:lstStyle/>
-          <a:p>
-            <a:pPr>
-              <a:defRPr/>
-            </a:pPr>
-            <a:endParaRPr/>
-          </a:p>
-        </p:txBody>
-      </p:sp>
-      <p:sp>
-        <p:nvSpPr>
-          <p:cNvPr id="62" name=""/>
-          <p:cNvSpPr/>
-          <p:nvPr/>
-        </p:nvSpPr>
-        <p:spPr bwMode="auto">
-          <a:xfrm>
-            <a:off x="2375490" y="2936694"/>
-            <a:ext cx="1439" cy="77755"/>
-          </a:xfrm>
-          <a:prstGeom prst="line">
-            <a:avLst/>
-          </a:prstGeom>
-          <a:ln w="12700">
-            <a:solidFill>
-              <a:srgbClr val="000000"/>
-            </a:solidFill>
-          </a:ln>
-          <a:effectLst/>
-        </p:spPr>
-        <p:txBody>
-          <a:bodyPr/>
-          <a:lstStyle/>
-          <a:p>
-            <a:pPr>
-              <a:defRPr/>
-            </a:pPr>
-            <a:endParaRPr/>
-          </a:p>
-        </p:txBody>
-      </p:sp>
-      <p:sp>
-        <p:nvSpPr>
-          <p:cNvPr id="63" name=""/>
-          <p:cNvSpPr/>
-          <p:nvPr/>
-        </p:nvSpPr>
-        <p:spPr bwMode="auto">
-          <a:xfrm>
-            <a:off x="8283078" y="3424464"/>
-            <a:ext cx="89993" cy="0"/>
-          </a:xfrm>
-          <a:prstGeom prst="line">
-            <a:avLst/>
-          </a:prstGeom>
-          <a:ln w="12700">
-            <a:solidFill>
-              <a:srgbClr val="000000"/>
-            </a:solidFill>
-          </a:ln>
-          <a:effectLst/>
-        </p:spPr>
-        <p:txBody>
-          <a:bodyPr/>
-          <a:lstStyle/>
-          <a:p>
-            <a:pPr>
-              <a:defRPr/>
-            </a:pPr>
-            <a:endParaRPr/>
-          </a:p>
-        </p:txBody>
-      </p:sp>
-      <p:sp>
-        <p:nvSpPr>
-          <p:cNvPr id="64" name=""/>
-          <p:cNvSpPr/>
-          <p:nvPr/>
-        </p:nvSpPr>
-        <p:spPr bwMode="auto">
-          <a:xfrm>
-            <a:off x="3421584" y="2063390"/>
-            <a:ext cx="0" cy="503608"/>
-          </a:xfrm>
-          <a:prstGeom prst="line">
-            <a:avLst/>
-          </a:prstGeom>
-          <a:ln w="12700">
-            <a:solidFill>
-              <a:srgbClr val="000000"/>
-            </a:solidFill>
-            <a:tailEnd type="triangle"/>
-          </a:ln>
-          <a:effectLst/>
-        </p:spPr>
-        <p:txBody>
-          <a:bodyPr/>
-          <a:lstStyle/>
-          <a:p>
-            <a:pPr>
-              <a:defRPr/>
-            </a:pPr>
-            <a:endParaRPr/>
-          </a:p>
-        </p:txBody>
-      </p:sp>
-      <p:sp>
-        <p:nvSpPr>
-          <p:cNvPr id="65" name=""/>
-          <p:cNvSpPr/>
-          <p:nvPr/>
-        </p:nvSpPr>
-        <p:spPr bwMode="auto">
-          <a:xfrm>
-            <a:off x="8236281" y="2063390"/>
-            <a:ext cx="0" cy="503608"/>
-          </a:xfrm>
-          <a:prstGeom prst="line">
-            <a:avLst/>
-          </a:prstGeom>
-          <a:ln w="12700">
-            <a:solidFill>
-              <a:srgbClr val="000000"/>
-            </a:solidFill>
-            <a:tailEnd type="triangle"/>
-          </a:ln>
-          <a:effectLst/>
-        </p:spPr>
-        <p:txBody>
-          <a:bodyPr/>
-          <a:lstStyle/>
-          <a:p>
-            <a:pPr>
-              <a:defRPr/>
-            </a:pPr>
-            <a:endParaRPr/>
-          </a:p>
-        </p:txBody>
-      </p:sp>
-      <p:sp>
-        <p:nvSpPr>
-          <p:cNvPr id="66" name=""/>
-          <p:cNvSpPr/>
-          <p:nvPr/>
-        </p:nvSpPr>
-        <p:spPr bwMode="auto">
-          <a:xfrm>
-            <a:off x="8236281" y="4071343"/>
-            <a:ext cx="0" cy="413973"/>
-          </a:xfrm>
-          <a:prstGeom prst="line">
-            <a:avLst/>
-          </a:prstGeom>
-          <a:ln w="12700">
-            <a:solidFill>
-              <a:srgbClr val="000000"/>
-            </a:solidFill>
-            <a:tailEnd type="triangle"/>
-          </a:ln>
-          <a:effectLst/>
-        </p:spPr>
-        <p:txBody>
-          <a:bodyPr/>
-          <a:lstStyle/>
-          <a:p>
-            <a:pPr>
-              <a:defRPr/>
-            </a:pPr>
-            <a:endParaRPr/>
-          </a:p>
-        </p:txBody>
-      </p:sp>
-      <p:sp>
-        <p:nvSpPr>
-          <p:cNvPr id="67" name=""/>
-          <p:cNvSpPr/>
-          <p:nvPr/>
-        </p:nvSpPr>
-        <p:spPr bwMode="auto">
-          <a:xfrm>
-            <a:off x="3421944" y="2065549"/>
-            <a:ext cx="1981315" cy="0"/>
-          </a:xfrm>
-          <a:prstGeom prst="line">
-            <a:avLst/>
-          </a:prstGeom>
-          <a:ln w="19050">
-            <a:solidFill>
-              <a:srgbClr val="000000"/>
-            </a:solidFill>
-          </a:ln>
-          <a:effectLst/>
-        </p:spPr>
-        <p:txBody>
-          <a:bodyPr/>
-          <a:lstStyle/>
-          <a:p>
-            <a:pPr>
-              <a:defRPr/>
-            </a:pPr>
-            <a:endParaRPr/>
-          </a:p>
-        </p:txBody>
-      </p:sp>
-      <p:sp>
-        <p:nvSpPr>
-          <p:cNvPr id="68" name=""/>
-          <p:cNvSpPr/>
-          <p:nvPr/>
-        </p:nvSpPr>
-        <p:spPr bwMode="auto">
-          <a:xfrm>
-            <a:off x="6224007" y="2065549"/>
-            <a:ext cx="2012273" cy="0"/>
-          </a:xfrm>
-          <a:prstGeom prst="line">
-            <a:avLst/>
-          </a:prstGeom>
-          <a:ln w="19050">
-            <a:solidFill>
-              <a:srgbClr val="000000"/>
-            </a:solidFill>
-          </a:ln>
-          <a:effectLst/>
-        </p:spPr>
-        <p:txBody>
-          <a:bodyPr/>
-          <a:lstStyle/>
-          <a:p>
-            <a:pPr>
-              <a:defRPr/>
-            </a:pPr>
-            <a:endParaRPr/>
-          </a:p>
-        </p:txBody>
-      </p:sp>
-      <p:sp>
-        <p:nvSpPr>
-          <p:cNvPr id="69" name=""/>
-          <p:cNvSpPr/>
-          <p:nvPr/>
-        </p:nvSpPr>
-        <p:spPr bwMode="auto">
-          <a:xfrm>
-            <a:off x="6436394" y="4863293"/>
-            <a:ext cx="1112329" cy="0"/>
-          </a:xfrm>
-          <a:prstGeom prst="line">
-            <a:avLst/>
-          </a:prstGeom>
-          <a:ln w="12700">
-            <a:solidFill>
-              <a:srgbClr val="000000"/>
-            </a:solidFill>
-            <a:tailEnd type="triangle"/>
-          </a:ln>
-          <a:effectLst/>
-        </p:spPr>
-        <p:txBody>
-          <a:bodyPr/>
-          <a:lstStyle/>
-          <a:p>
-            <a:pPr>
-              <a:defRPr/>
-            </a:pPr>
-            <a:endParaRPr/>
-          </a:p>
-        </p:txBody>
-      </p:sp>
-      <p:sp>
-        <p:nvSpPr>
-          <p:cNvPr id="70" name=""/>
-          <p:cNvSpPr txBox="1"/>
-          <p:nvPr/>
-        </p:nvSpPr>
-        <p:spPr bwMode="auto">
-          <a:xfrm>
-            <a:off x="7613520" y="4571712"/>
-            <a:ext cx="1240121" cy="579563"/>
-          </a:xfrm>
-          <a:prstGeom prst="rect">
-            <a:avLst/>
-          </a:prstGeom>
-          <a:noFill/>
-          <a:ln>
-            <a:noFill/>
-          </a:ln>
-          <a:effectLst/>
-        </p:spPr>
-        <p:txBody>
-          <a:bodyPr lIns="91440" tIns="45720" rIns="91440" bIns="45720" anchor="t">
-            <a:spAutoFit/>
-          </a:bodyPr>
-          <a:lstStyle/>
-          <a:p>
-            <a:pPr algn="ctr">
-              <a:defRPr/>
-            </a:pPr>
-            <a:r>
-              <a:rPr sz="1600" b="1"/>
-              <a:t>LOSS FUNCTION</a:t>
-            </a:r>
             <a:endParaRPr/>
           </a:p>
         </p:txBody>
       </p:sp>
       <p:cxnSp>
         <p:nvCxnSpPr>
-          <p:cNvPr id="71" name=""/>
+          <p:cNvPr id="0" name=""/>
+          <p:cNvCxnSpPr>
+            <a:cxnSpLocks/>
+            <a:stCxn id="49" idx="7"/>
+            <a:endCxn id="52" idx="2"/>
+          </p:cNvCxnSpPr>
+          <p:nvPr/>
+        </p:nvCxnSpPr>
+        <p:spPr bwMode="auto">
+          <a:xfrm rot="16199969" flipH="0" flipV="0">
+            <a:off x="7977922" y="3095974"/>
+            <a:ext cx="73266" cy="105070"/>
+          </a:xfrm>
+          <a:prstGeom prst="line">
+            <a:avLst/>
+          </a:prstGeom>
+          <a:ln w="19049" cap="flat" cmpd="sng" algn="ctr">
+            <a:solidFill>
+              <a:schemeClr val="tx1"/>
+            </a:solidFill>
+            <a:prstDash val="solid"/>
+            <a:miter lim="800000"/>
+          </a:ln>
+        </p:spPr>
+        <p:style>
+          <a:lnRef idx="1">
+            <a:schemeClr val="accent1">
+              <a:shade val="50000"/>
+            </a:schemeClr>
+          </a:lnRef>
+          <a:fillRef idx="0">
+            <a:schemeClr val="accent1"/>
+          </a:fillRef>
+          <a:effectRef idx="0">
+            <a:schemeClr val="accent1"/>
+          </a:effectRef>
+          <a:fontRef idx="minor">
+            <a:schemeClr val="tx1"/>
+          </a:fontRef>
+        </p:style>
+      </p:cxnSp>
+      <p:cxnSp>
+        <p:nvCxnSpPr>
+          <p:cNvPr id="132909191" name=""/>
+          <p:cNvCxnSpPr>
+            <a:cxnSpLocks/>
+            <a:stCxn id="51" idx="2"/>
+            <a:endCxn id="50" idx="7"/>
+          </p:cNvCxnSpPr>
+          <p:nvPr/>
+        </p:nvCxnSpPr>
+        <p:spPr bwMode="auto">
+          <a:xfrm rot="10799990" flipH="0" flipV="1">
+            <a:off x="7962020" y="3427936"/>
+            <a:ext cx="105070" cy="93065"/>
+          </a:xfrm>
+          <a:prstGeom prst="line">
+            <a:avLst/>
+          </a:prstGeom>
+          <a:ln w="19049" cap="flat" cmpd="sng" algn="ctr">
+            <a:solidFill>
+              <a:schemeClr val="tx1"/>
+            </a:solidFill>
+            <a:prstDash val="solid"/>
+            <a:miter lim="800000"/>
+          </a:ln>
+        </p:spPr>
+        <p:style>
+          <a:lnRef idx="1">
+            <a:schemeClr val="accent1">
+              <a:shade val="50000"/>
+            </a:schemeClr>
+          </a:lnRef>
+          <a:fillRef idx="0">
+            <a:schemeClr val="accent1"/>
+          </a:fillRef>
+          <a:effectRef idx="0">
+            <a:schemeClr val="accent1"/>
+          </a:effectRef>
+          <a:fontRef idx="minor">
+            <a:schemeClr val="tx1"/>
+          </a:fontRef>
+        </p:style>
+      </p:cxnSp>
+      <p:cxnSp>
+        <p:nvCxnSpPr>
+          <p:cNvPr id="539651743" name=""/>
+          <p:cNvCxnSpPr>
+            <a:cxnSpLocks/>
+            <a:stCxn id="49" idx="5"/>
+            <a:endCxn id="53" idx="1"/>
+          </p:cNvCxnSpPr>
+          <p:nvPr/>
+        </p:nvCxnSpPr>
+        <p:spPr bwMode="auto">
+          <a:xfrm rot="5399978" flipH="0" flipV="1">
+            <a:off x="7872206" y="3426486"/>
+            <a:ext cx="316081" cy="136452"/>
+          </a:xfrm>
+          <a:prstGeom prst="line">
+            <a:avLst/>
+          </a:prstGeom>
+          <a:ln w="19049" cap="flat" cmpd="sng" algn="ctr">
+            <a:solidFill>
+              <a:schemeClr val="tx1"/>
+            </a:solidFill>
+            <a:prstDash val="solid"/>
+            <a:miter lim="800000"/>
+          </a:ln>
+        </p:spPr>
+        <p:style>
+          <a:lnRef idx="1">
+            <a:schemeClr val="accent1">
+              <a:shade val="50000"/>
+            </a:schemeClr>
+          </a:lnRef>
+          <a:fillRef idx="0">
+            <a:schemeClr val="accent1"/>
+          </a:fillRef>
+          <a:effectRef idx="0">
+            <a:schemeClr val="accent1"/>
+          </a:effectRef>
+          <a:fontRef idx="minor">
+            <a:schemeClr val="tx1"/>
+          </a:fontRef>
+        </p:style>
+      </p:cxnSp>
+      <p:cxnSp>
+        <p:nvCxnSpPr>
+          <p:cNvPr id="1525626555" name=""/>
+          <p:cNvCxnSpPr>
+            <a:cxnSpLocks/>
+            <a:stCxn id="50" idx="7"/>
+            <a:endCxn id="52" idx="3"/>
+          </p:cNvCxnSpPr>
+          <p:nvPr/>
+        </p:nvCxnSpPr>
+        <p:spPr bwMode="auto">
+          <a:xfrm rot="16199969" flipH="0" flipV="0">
+            <a:off x="7863566" y="3286095"/>
+            <a:ext cx="333361" cy="136452"/>
+          </a:xfrm>
+          <a:prstGeom prst="line">
+            <a:avLst/>
+          </a:prstGeom>
+          <a:ln w="19049" cap="flat" cmpd="sng" algn="ctr">
+            <a:solidFill>
+              <a:schemeClr val="tx1"/>
+            </a:solidFill>
+            <a:prstDash val="solid"/>
+            <a:miter lim="800000"/>
+          </a:ln>
+        </p:spPr>
+        <p:style>
+          <a:lnRef idx="1">
+            <a:schemeClr val="accent1">
+              <a:shade val="50000"/>
+            </a:schemeClr>
+          </a:lnRef>
+          <a:fillRef idx="0">
+            <a:schemeClr val="accent1"/>
+          </a:fillRef>
+          <a:effectRef idx="0">
+            <a:schemeClr val="accent1"/>
+          </a:effectRef>
+          <a:fontRef idx="minor">
+            <a:schemeClr val="tx1"/>
+          </a:fontRef>
+        </p:style>
+      </p:cxnSp>
+      <p:cxnSp>
+        <p:nvCxnSpPr>
+          <p:cNvPr id="1669056380" name=""/>
+          <p:cNvCxnSpPr>
+            <a:cxnSpLocks/>
+            <a:stCxn id="51" idx="2"/>
+            <a:endCxn id="49" idx="5"/>
+          </p:cNvCxnSpPr>
+          <p:nvPr/>
+        </p:nvCxnSpPr>
+        <p:spPr bwMode="auto">
+          <a:xfrm rot="10799990" flipH="0" flipV="0">
+            <a:off x="7962020" y="3336672"/>
+            <a:ext cx="105070" cy="91264"/>
+          </a:xfrm>
+          <a:prstGeom prst="line">
+            <a:avLst/>
+          </a:prstGeom>
+          <a:ln w="19049" cap="flat" cmpd="sng" algn="ctr">
+            <a:solidFill>
+              <a:schemeClr val="tx1"/>
+            </a:solidFill>
+            <a:prstDash val="solid"/>
+            <a:miter lim="800000"/>
+          </a:ln>
+        </p:spPr>
+        <p:style>
+          <a:lnRef idx="1">
+            <a:schemeClr val="accent1">
+              <a:shade val="50000"/>
+            </a:schemeClr>
+          </a:lnRef>
+          <a:fillRef idx="0">
+            <a:schemeClr val="accent1"/>
+          </a:fillRef>
+          <a:effectRef idx="0">
+            <a:schemeClr val="accent1"/>
+          </a:effectRef>
+          <a:fontRef idx="minor">
+            <a:schemeClr val="tx1"/>
+          </a:fontRef>
+        </p:style>
+      </p:cxnSp>
+      <p:cxnSp>
+        <p:nvCxnSpPr>
+          <p:cNvPr id="342108558" name=""/>
+          <p:cNvCxnSpPr>
+            <a:cxnSpLocks/>
+            <a:stCxn id="54" idx="1"/>
+            <a:endCxn id="52" idx="5"/>
+          </p:cNvCxnSpPr>
+          <p:nvPr/>
+        </p:nvCxnSpPr>
+        <p:spPr bwMode="auto">
+          <a:xfrm rot="16199969" flipH="0" flipV="1">
+            <a:off x="8248562" y="3189081"/>
+            <a:ext cx="157332" cy="154452"/>
+          </a:xfrm>
+          <a:prstGeom prst="line">
+            <a:avLst/>
+          </a:prstGeom>
+          <a:ln w="19049" cap="flat" cmpd="sng" algn="ctr">
+            <a:solidFill>
+              <a:schemeClr val="tx1"/>
+            </a:solidFill>
+            <a:prstDash val="solid"/>
+            <a:miter lim="800000"/>
+          </a:ln>
+        </p:spPr>
+        <p:style>
+          <a:lnRef idx="1">
+            <a:schemeClr val="accent1">
+              <a:shade val="50000"/>
+            </a:schemeClr>
+          </a:lnRef>
+          <a:fillRef idx="0">
+            <a:schemeClr val="accent1"/>
+          </a:fillRef>
+          <a:effectRef idx="0">
+            <a:schemeClr val="accent1"/>
+          </a:effectRef>
+          <a:fontRef idx="minor">
+            <a:schemeClr val="tx1"/>
+          </a:fontRef>
+        </p:style>
+      </p:cxnSp>
+      <p:cxnSp>
+        <p:nvCxnSpPr>
+          <p:cNvPr id="880833501" name=""/>
+          <p:cNvCxnSpPr>
+            <a:cxnSpLocks/>
+            <a:stCxn id="53" idx="7"/>
+            <a:endCxn id="54" idx="3"/>
+          </p:cNvCxnSpPr>
+          <p:nvPr/>
+        </p:nvCxnSpPr>
+        <p:spPr bwMode="auto">
+          <a:xfrm rot="16199969" flipH="0" flipV="0">
+            <a:off x="8249102" y="3497401"/>
+            <a:ext cx="156251" cy="154452"/>
+          </a:xfrm>
+          <a:prstGeom prst="line">
+            <a:avLst/>
+          </a:prstGeom>
+          <a:ln w="19049" cap="flat" cmpd="sng" algn="ctr">
+            <a:solidFill>
+              <a:schemeClr val="tx1"/>
+            </a:solidFill>
+            <a:prstDash val="solid"/>
+            <a:miter lim="800000"/>
+          </a:ln>
+        </p:spPr>
+        <p:style>
+          <a:lnRef idx="1">
+            <a:schemeClr val="accent1">
+              <a:shade val="50000"/>
+            </a:schemeClr>
+          </a:lnRef>
+          <a:fillRef idx="0">
+            <a:schemeClr val="accent1"/>
+          </a:fillRef>
+          <a:effectRef idx="0">
+            <a:schemeClr val="accent1"/>
+          </a:effectRef>
+          <a:fontRef idx="minor">
+            <a:schemeClr val="tx1"/>
+          </a:fontRef>
+        </p:style>
+      </p:cxnSp>
+      <p:sp>
+        <p:nvSpPr>
+          <p:cNvPr id="906130604" name=""/>
+          <p:cNvSpPr/>
+          <p:nvPr/>
+        </p:nvSpPr>
+        <p:spPr bwMode="auto">
+          <a:xfrm>
+            <a:off x="3026454" y="3182558"/>
+            <a:ext cx="214293" cy="214293"/>
+          </a:xfrm>
+          <a:prstGeom prst="ellipse">
+            <a:avLst/>
+          </a:prstGeom>
+          <a:noFill/>
+          <a:ln w="12700">
+            <a:solidFill>
+              <a:srgbClr val="000000"/>
+            </a:solidFill>
+          </a:ln>
+          <a:effectLst/>
+        </p:spPr>
+        <p:txBody>
+          <a:bodyPr/>
+          <a:lstStyle/>
+          <a:p>
+            <a:pPr>
+              <a:defRPr/>
+            </a:pPr>
+            <a:endParaRPr/>
+          </a:p>
+        </p:txBody>
+      </p:sp>
+      <p:sp>
+        <p:nvSpPr>
+          <p:cNvPr id="1768421233" name=""/>
+          <p:cNvSpPr/>
+          <p:nvPr/>
+        </p:nvSpPr>
+        <p:spPr bwMode="auto">
+          <a:xfrm>
+            <a:off x="3026454" y="3518417"/>
+            <a:ext cx="214293" cy="214293"/>
+          </a:xfrm>
+          <a:prstGeom prst="ellipse">
+            <a:avLst/>
+          </a:prstGeom>
+          <a:noFill/>
+          <a:ln w="12700">
+            <a:solidFill>
+              <a:srgbClr val="000000"/>
+            </a:solidFill>
+          </a:ln>
+          <a:effectLst/>
+        </p:spPr>
+        <p:txBody>
+          <a:bodyPr/>
+          <a:lstStyle/>
+          <a:p>
+            <a:pPr>
+              <a:defRPr/>
+            </a:pPr>
+            <a:endParaRPr/>
+          </a:p>
+        </p:txBody>
+      </p:sp>
+      <p:sp>
+        <p:nvSpPr>
+          <p:cNvPr id="393535095" name=""/>
+          <p:cNvSpPr/>
+          <p:nvPr/>
+        </p:nvSpPr>
+        <p:spPr bwMode="auto">
+          <a:xfrm>
+            <a:off x="3314436" y="3349587"/>
+            <a:ext cx="214293" cy="214293"/>
+          </a:xfrm>
+          <a:prstGeom prst="ellipse">
+            <a:avLst/>
+          </a:prstGeom>
+          <a:noFill/>
+          <a:ln w="12700">
+            <a:solidFill>
+              <a:srgbClr val="000000"/>
+            </a:solidFill>
+          </a:ln>
+          <a:effectLst/>
+        </p:spPr>
+        <p:txBody>
+          <a:bodyPr/>
+          <a:lstStyle/>
+          <a:p>
+            <a:pPr>
+              <a:defRPr/>
+            </a:pPr>
+            <a:endParaRPr/>
+          </a:p>
+        </p:txBody>
+      </p:sp>
+      <p:sp>
+        <p:nvSpPr>
+          <p:cNvPr id="293436469" name=""/>
+          <p:cNvSpPr/>
+          <p:nvPr/>
+        </p:nvSpPr>
+        <p:spPr bwMode="auto">
+          <a:xfrm>
+            <a:off x="3314436" y="3033527"/>
+            <a:ext cx="214293" cy="214293"/>
+          </a:xfrm>
+          <a:prstGeom prst="ellipse">
+            <a:avLst/>
+          </a:prstGeom>
+          <a:noFill/>
+          <a:ln w="12700">
+            <a:solidFill>
+              <a:srgbClr val="000000"/>
+            </a:solidFill>
+          </a:ln>
+          <a:effectLst/>
+        </p:spPr>
+        <p:txBody>
+          <a:bodyPr/>
+          <a:lstStyle/>
+          <a:p>
+            <a:pPr>
+              <a:defRPr/>
+            </a:pPr>
+            <a:endParaRPr/>
+          </a:p>
+        </p:txBody>
+      </p:sp>
+      <p:sp>
+        <p:nvSpPr>
+          <p:cNvPr id="291515968" name=""/>
+          <p:cNvSpPr/>
+          <p:nvPr/>
+        </p:nvSpPr>
+        <p:spPr bwMode="auto">
+          <a:xfrm>
+            <a:off x="3314436" y="3650168"/>
+            <a:ext cx="214293" cy="214293"/>
+          </a:xfrm>
+          <a:prstGeom prst="ellipse">
+            <a:avLst/>
+          </a:prstGeom>
+          <a:noFill/>
+          <a:ln w="12700">
+            <a:solidFill>
+              <a:srgbClr val="000000"/>
+            </a:solidFill>
+          </a:ln>
+          <a:effectLst/>
+        </p:spPr>
+        <p:txBody>
+          <a:bodyPr/>
+          <a:lstStyle/>
+          <a:p>
+            <a:pPr>
+              <a:defRPr/>
+            </a:pPr>
+            <a:endParaRPr/>
+          </a:p>
+        </p:txBody>
+      </p:sp>
+      <p:sp>
+        <p:nvSpPr>
+          <p:cNvPr id="824312670" name=""/>
+          <p:cNvSpPr/>
+          <p:nvPr/>
+        </p:nvSpPr>
+        <p:spPr bwMode="auto">
+          <a:xfrm>
+            <a:off x="3620417" y="3342388"/>
+            <a:ext cx="214293" cy="214293"/>
+          </a:xfrm>
+          <a:prstGeom prst="ellipse">
+            <a:avLst/>
+          </a:prstGeom>
+          <a:noFill/>
+          <a:ln w="12700">
+            <a:solidFill>
+              <a:srgbClr val="000000"/>
+            </a:solidFill>
+          </a:ln>
+          <a:effectLst/>
+        </p:spPr>
+        <p:txBody>
+          <a:bodyPr/>
+          <a:lstStyle/>
+          <a:p>
+            <a:pPr>
+              <a:defRPr/>
+            </a:pPr>
+            <a:endParaRPr/>
+          </a:p>
+        </p:txBody>
+      </p:sp>
+      <p:sp>
+        <p:nvSpPr>
+          <p:cNvPr id="900273967" name=""/>
+          <p:cNvSpPr/>
+          <p:nvPr/>
+        </p:nvSpPr>
+        <p:spPr bwMode="auto">
+          <a:xfrm>
+            <a:off x="3210043" y="3700566"/>
+            <a:ext cx="104392" cy="57595"/>
+          </a:xfrm>
+          <a:prstGeom prst="line">
+            <a:avLst/>
+          </a:prstGeom>
+          <a:ln w="12700">
+            <a:solidFill>
+              <a:srgbClr val="000000"/>
+            </a:solidFill>
+          </a:ln>
+          <a:effectLst/>
+        </p:spPr>
+        <p:txBody>
+          <a:bodyPr/>
+          <a:lstStyle/>
+          <a:p>
+            <a:pPr>
+              <a:defRPr/>
+            </a:pPr>
+            <a:endParaRPr/>
+          </a:p>
+        </p:txBody>
+      </p:sp>
+      <p:sp>
+        <p:nvSpPr>
+          <p:cNvPr id="1733121629" name=""/>
+          <p:cNvSpPr/>
+          <p:nvPr/>
+        </p:nvSpPr>
+        <p:spPr bwMode="auto">
+          <a:xfrm>
+            <a:off x="3530423" y="3453261"/>
+            <a:ext cx="89992" cy="0"/>
+          </a:xfrm>
+          <a:prstGeom prst="line">
+            <a:avLst/>
+          </a:prstGeom>
+          <a:ln w="12700">
+            <a:solidFill>
+              <a:srgbClr val="000000"/>
+            </a:solidFill>
+          </a:ln>
+          <a:effectLst/>
+        </p:spPr>
+        <p:txBody>
+          <a:bodyPr/>
+          <a:lstStyle/>
+          <a:p>
+            <a:pPr>
+              <a:defRPr/>
+            </a:pPr>
+            <a:endParaRPr/>
+          </a:p>
+        </p:txBody>
+      </p:sp>
+      <p:cxnSp>
+        <p:nvCxnSpPr>
+          <p:cNvPr id="464608297" name=""/>
           <p:cNvCxnSpPr>
             <a:cxnSpLocks/>
           </p:cNvCxnSpPr>
           <p:nvPr/>
         </p:nvCxnSpPr>
         <p:spPr bwMode="auto">
-          <a:xfrm>
-            <a:off x="8632256" y="3718565"/>
-            <a:ext cx="46797" cy="1065532"/>
-          </a:xfrm>
-          <a:prstGeom prst="curvedConnector5">
-            <a:avLst>
-              <a:gd name="adj1" fmla="val 50000"/>
-              <a:gd name="adj2" fmla="val 50000"/>
-              <a:gd name="adj3" fmla="val 50000"/>
-            </a:avLst>
-          </a:prstGeom>
-          <a:ln w="28575">
-            <a:solidFill>
-              <a:srgbClr val="C00000"/>
-            </a:solidFill>
-            <a:prstDash val="dash"/>
-            <a:tailEnd type="triangle"/>
-          </a:ln>
-          <a:effectLst/>
-        </p:spPr>
+          <a:xfrm rot="16199969" flipH="0" flipV="0">
+            <a:off x="3225267" y="3124773"/>
+            <a:ext cx="73265" cy="105069"/>
+          </a:xfrm>
+          <a:prstGeom prst="line">
+            <a:avLst/>
+          </a:prstGeom>
+          <a:ln w="19049" cap="flat" cmpd="sng" algn="ctr">
+            <a:solidFill>
+              <a:schemeClr val="tx1"/>
+            </a:solidFill>
+            <a:prstDash val="solid"/>
+            <a:miter lim="800000"/>
+          </a:ln>
+        </p:spPr>
+        <p:style>
+          <a:lnRef idx="1">
+            <a:schemeClr val="accent1">
+              <a:shade val="50000"/>
+            </a:schemeClr>
+          </a:lnRef>
+          <a:fillRef idx="0">
+            <a:schemeClr val="accent1"/>
+          </a:fillRef>
+          <a:effectRef idx="0">
+            <a:schemeClr val="accent1"/>
+          </a:effectRef>
+          <a:fontRef idx="minor">
+            <a:schemeClr val="tx1"/>
+          </a:fontRef>
+        </p:style>
       </p:cxnSp>
-      <p:sp>
-        <p:nvSpPr>
-          <p:cNvPr id="72" name=""/>
-          <p:cNvSpPr txBox="1"/>
-          <p:nvPr/>
-        </p:nvSpPr>
-        <p:spPr bwMode="auto">
-          <a:xfrm>
-            <a:off x="8153486" y="4035345"/>
-            <a:ext cx="961859" cy="426933"/>
-          </a:xfrm>
-          <a:prstGeom prst="rect">
-            <a:avLst/>
-          </a:prstGeom>
-          <a:noFill/>
-          <a:ln>
-            <a:noFill/>
-          </a:ln>
-          <a:effectLst/>
-        </p:spPr>
-        <p:txBody>
-          <a:bodyPr lIns="91440" tIns="45720" rIns="91440" bIns="45720" anchor="t">
-            <a:spAutoFit/>
-          </a:bodyPr>
-          <a:lstStyle/>
-          <a:p>
-            <a:pPr algn="r">
-              <a:defRPr/>
-            </a:pPr>
-            <a:r>
-              <a:rPr sz="1100">
-                <a:solidFill>
-                  <a:srgbClr val="C00000"/>
-                </a:solidFill>
-              </a:rPr>
-              <a:t>back-propagation</a:t>
-            </a:r>
-            <a:endParaRPr/>
-          </a:p>
-        </p:txBody>
-      </p:sp>
-      <p:sp>
-        <p:nvSpPr>
-          <p:cNvPr id="73" name=""/>
-          <p:cNvSpPr txBox="1"/>
-          <p:nvPr/>
-        </p:nvSpPr>
-        <p:spPr bwMode="auto">
-          <a:xfrm>
-            <a:off x="4197335" y="2737627"/>
-            <a:ext cx="1228962" cy="239995"/>
-          </a:xfrm>
-          <a:prstGeom prst="rect">
-            <a:avLst/>
-          </a:prstGeom>
-          <a:noFill/>
-          <a:ln w="19050">
-            <a:solidFill>
-              <a:srgbClr val="205967"/>
-            </a:solidFill>
-            <a:prstDash val="dash"/>
-          </a:ln>
-          <a:effectLst/>
-        </p:spPr>
-        <p:txBody>
-          <a:bodyPr lIns="36004" tIns="36004" rIns="36004" bIns="36004" anchor="t">
-            <a:spAutoFit/>
-          </a:bodyPr>
-          <a:lstStyle/>
-          <a:p>
-            <a:pPr marL="0" algn="ctr">
-              <a:lnSpc>
-                <a:spcPct val="100000"/>
-              </a:lnSpc>
-              <a:defRPr/>
-            </a:pPr>
-            <a:r>
-              <a:rPr sz="1100" strike="noStrike">
-                <a:solidFill>
-                  <a:srgbClr val="000000"/>
-                </a:solidFill>
-                <a:latin typeface="Cantarell"/>
-                <a:cs typeface="Cantarell"/>
-              </a:rPr>
-              <a:t>m</a:t>
-            </a:r>
-            <a:r>
-              <a:rPr sz="1100" strike="noStrike" baseline="-25000">
-                <a:solidFill>
-                  <a:srgbClr val="000000"/>
-                </a:solidFill>
-                <a:latin typeface="Cantarell"/>
-                <a:cs typeface="Cantarell"/>
-              </a:rPr>
-              <a:t>0</a:t>
-            </a:r>
-            <a:endParaRPr/>
-          </a:p>
-          <a:p>
-            <a:pPr marL="0" algn="ctr">
-              <a:lnSpc>
-                <a:spcPct val="100000"/>
-              </a:lnSpc>
-              <a:defRPr/>
-            </a:pPr>
-            <a:r>
-              <a:rPr sz="1100" strike="noStrike">
-                <a:solidFill>
-                  <a:srgbClr val="000000"/>
-                </a:solidFill>
-                <a:latin typeface="Cantarell"/>
-                <a:cs typeface="Cantarell"/>
-              </a:rPr>
-              <a:t>m</a:t>
-            </a:r>
-            <a:r>
-              <a:rPr sz="1100" strike="noStrike" baseline="-25000">
-                <a:solidFill>
-                  <a:srgbClr val="000000"/>
-                </a:solidFill>
-                <a:latin typeface="Cantarell"/>
-                <a:cs typeface="Cantarell"/>
-              </a:rPr>
-              <a:t>1</a:t>
-            </a:r>
-            <a:endParaRPr/>
-          </a:p>
-          <a:p>
-            <a:pPr marL="0" algn="ctr">
-              <a:lnSpc>
-                <a:spcPct val="100000"/>
-              </a:lnSpc>
-              <a:defRPr/>
-            </a:pPr>
-            <a:r>
-              <a:rPr sz="1100" strike="noStrike">
-                <a:solidFill>
-                  <a:srgbClr val="000000"/>
-                </a:solidFill>
-                <a:latin typeface="Cantarell"/>
-                <a:cs typeface="Cantarell"/>
-              </a:rPr>
-              <a:t>&lt;eos&gt;</a:t>
-            </a:r>
-            <a:endParaRPr/>
-          </a:p>
-        </p:txBody>
-      </p:sp>
-      <p:sp>
-        <p:nvSpPr>
-          <p:cNvPr id="74" name=""/>
-          <p:cNvSpPr/>
-          <p:nvPr/>
-        </p:nvSpPr>
-        <p:spPr bwMode="auto">
-          <a:xfrm>
-            <a:off x="6274404" y="3434183"/>
-            <a:ext cx="161989" cy="0"/>
-          </a:xfrm>
-          <a:prstGeom prst="line">
-            <a:avLst/>
-          </a:prstGeom>
-          <a:ln w="12700">
-            <a:solidFill>
-              <a:srgbClr val="000000"/>
-            </a:solidFill>
-            <a:tailEnd type="triangle"/>
-          </a:ln>
-          <a:effectLst/>
-        </p:spPr>
-        <p:txBody>
-          <a:bodyPr/>
-          <a:lstStyle/>
-          <a:p>
-            <a:pPr>
-              <a:defRPr/>
-            </a:pPr>
-            <a:endParaRPr/>
-          </a:p>
-        </p:txBody>
-      </p:sp>
+      <p:cxnSp>
+        <p:nvCxnSpPr>
+          <p:cNvPr id="1147953108" name=""/>
+          <p:cNvCxnSpPr>
+            <a:cxnSpLocks/>
+          </p:cNvCxnSpPr>
+          <p:nvPr/>
+        </p:nvCxnSpPr>
+        <p:spPr bwMode="auto">
+          <a:xfrm rot="5399978" flipH="0" flipV="1">
+            <a:off x="3119551" y="3455283"/>
+            <a:ext cx="316080" cy="136452"/>
+          </a:xfrm>
+          <a:prstGeom prst="line">
+            <a:avLst/>
+          </a:prstGeom>
+          <a:ln w="19049" cap="flat" cmpd="sng" algn="ctr">
+            <a:solidFill>
+              <a:schemeClr val="tx1"/>
+            </a:solidFill>
+            <a:prstDash val="solid"/>
+            <a:miter lim="800000"/>
+          </a:ln>
+        </p:spPr>
+        <p:style>
+          <a:lnRef idx="1">
+            <a:schemeClr val="accent1">
+              <a:shade val="50000"/>
+            </a:schemeClr>
+          </a:lnRef>
+          <a:fillRef idx="0">
+            <a:schemeClr val="accent1"/>
+          </a:fillRef>
+          <a:effectRef idx="0">
+            <a:schemeClr val="accent1"/>
+          </a:effectRef>
+          <a:fontRef idx="minor">
+            <a:schemeClr val="tx1"/>
+          </a:fontRef>
+        </p:style>
+      </p:cxnSp>
+      <p:cxnSp>
+        <p:nvCxnSpPr>
+          <p:cNvPr id="1716033814" name=""/>
+          <p:cNvCxnSpPr>
+            <a:cxnSpLocks/>
+          </p:cNvCxnSpPr>
+          <p:nvPr/>
+        </p:nvCxnSpPr>
+        <p:spPr bwMode="auto">
+          <a:xfrm rot="16199969" flipH="0" flipV="0">
+            <a:off x="3110911" y="3314892"/>
+            <a:ext cx="333360" cy="136452"/>
+          </a:xfrm>
+          <a:prstGeom prst="line">
+            <a:avLst/>
+          </a:prstGeom>
+          <a:ln w="19049" cap="flat" cmpd="sng" algn="ctr">
+            <a:solidFill>
+              <a:schemeClr val="tx1"/>
+            </a:solidFill>
+            <a:prstDash val="solid"/>
+            <a:miter lim="800000"/>
+          </a:ln>
+        </p:spPr>
+        <p:style>
+          <a:lnRef idx="1">
+            <a:schemeClr val="accent1">
+              <a:shade val="50000"/>
+            </a:schemeClr>
+          </a:lnRef>
+          <a:fillRef idx="0">
+            <a:schemeClr val="accent1"/>
+          </a:fillRef>
+          <a:effectRef idx="0">
+            <a:schemeClr val="accent1"/>
+          </a:effectRef>
+          <a:fontRef idx="minor">
+            <a:schemeClr val="tx1"/>
+          </a:fontRef>
+        </p:style>
+      </p:cxnSp>
+      <p:cxnSp>
+        <p:nvCxnSpPr>
+          <p:cNvPr id="1133133356" name=""/>
+          <p:cNvCxnSpPr>
+            <a:cxnSpLocks/>
+          </p:cNvCxnSpPr>
+          <p:nvPr/>
+        </p:nvCxnSpPr>
+        <p:spPr bwMode="auto">
+          <a:xfrm rot="10799990" flipH="0" flipV="0">
+            <a:off x="3209365" y="3365469"/>
+            <a:ext cx="105069" cy="91263"/>
+          </a:xfrm>
+          <a:prstGeom prst="line">
+            <a:avLst/>
+          </a:prstGeom>
+          <a:ln w="19049" cap="flat" cmpd="sng" algn="ctr">
+            <a:solidFill>
+              <a:schemeClr val="tx1"/>
+            </a:solidFill>
+            <a:prstDash val="solid"/>
+            <a:miter lim="800000"/>
+          </a:ln>
+        </p:spPr>
+        <p:style>
+          <a:lnRef idx="1">
+            <a:schemeClr val="accent1">
+              <a:shade val="50000"/>
+            </a:schemeClr>
+          </a:lnRef>
+          <a:fillRef idx="0">
+            <a:schemeClr val="accent1"/>
+          </a:fillRef>
+          <a:effectRef idx="0">
+            <a:schemeClr val="accent1"/>
+          </a:effectRef>
+          <a:fontRef idx="minor">
+            <a:schemeClr val="tx1"/>
+          </a:fontRef>
+        </p:style>
+      </p:cxnSp>
+      <p:cxnSp>
+        <p:nvCxnSpPr>
+          <p:cNvPr id="1139223121" name=""/>
+          <p:cNvCxnSpPr>
+            <a:cxnSpLocks/>
+          </p:cNvCxnSpPr>
+          <p:nvPr/>
+        </p:nvCxnSpPr>
+        <p:spPr bwMode="auto">
+          <a:xfrm rot="16199969" flipH="0" flipV="1">
+            <a:off x="3495907" y="3217878"/>
+            <a:ext cx="157331" cy="154451"/>
+          </a:xfrm>
+          <a:prstGeom prst="line">
+            <a:avLst/>
+          </a:prstGeom>
+          <a:ln w="19049" cap="flat" cmpd="sng" algn="ctr">
+            <a:solidFill>
+              <a:schemeClr val="tx1"/>
+            </a:solidFill>
+            <a:prstDash val="solid"/>
+            <a:miter lim="800000"/>
+          </a:ln>
+        </p:spPr>
+        <p:style>
+          <a:lnRef idx="1">
+            <a:schemeClr val="accent1">
+              <a:shade val="50000"/>
+            </a:schemeClr>
+          </a:lnRef>
+          <a:fillRef idx="0">
+            <a:schemeClr val="accent1"/>
+          </a:fillRef>
+          <a:effectRef idx="0">
+            <a:schemeClr val="accent1"/>
+          </a:effectRef>
+          <a:fontRef idx="minor">
+            <a:schemeClr val="tx1"/>
+          </a:fontRef>
+        </p:style>
+      </p:cxnSp>
+      <p:cxnSp>
+        <p:nvCxnSpPr>
+          <p:cNvPr id="1775844913" name=""/>
+          <p:cNvCxnSpPr>
+            <a:cxnSpLocks/>
+          </p:cNvCxnSpPr>
+          <p:nvPr/>
+        </p:nvCxnSpPr>
+        <p:spPr bwMode="auto">
+          <a:xfrm rot="16199969" flipH="0" flipV="0">
+            <a:off x="3496447" y="3526198"/>
+            <a:ext cx="156250" cy="154451"/>
+          </a:xfrm>
+          <a:prstGeom prst="line">
+            <a:avLst/>
+          </a:prstGeom>
+          <a:ln w="19049" cap="flat" cmpd="sng" algn="ctr">
+            <a:solidFill>
+              <a:schemeClr val="tx1"/>
+            </a:solidFill>
+            <a:prstDash val="solid"/>
+            <a:miter lim="800000"/>
+          </a:ln>
+        </p:spPr>
+        <p:style>
+          <a:lnRef idx="1">
+            <a:schemeClr val="accent1">
+              <a:shade val="50000"/>
+            </a:schemeClr>
+          </a:lnRef>
+          <a:fillRef idx="0">
+            <a:schemeClr val="accent1"/>
+          </a:fillRef>
+          <a:effectRef idx="0">
+            <a:schemeClr val="accent1"/>
+          </a:effectRef>
+          <a:fontRef idx="minor">
+            <a:schemeClr val="tx1"/>
+          </a:fontRef>
+        </p:style>
+      </p:cxnSp>
+      <p:cxnSp>
+        <p:nvCxnSpPr>
+          <p:cNvPr id="1825025811" name=""/>
+          <p:cNvCxnSpPr>
+            <a:cxnSpLocks/>
+            <a:stCxn id="1768421233" idx="7"/>
+            <a:endCxn id="393535095" idx="2"/>
+          </p:cNvCxnSpPr>
+          <p:nvPr/>
+        </p:nvCxnSpPr>
+        <p:spPr bwMode="auto">
+          <a:xfrm rot="16199969" flipH="0" flipV="0">
+            <a:off x="3215368" y="3450732"/>
+            <a:ext cx="93065" cy="105070"/>
+          </a:xfrm>
+          <a:prstGeom prst="line">
+            <a:avLst/>
+          </a:prstGeom>
+          <a:ln w="19049" cap="flat" cmpd="sng" algn="ctr">
+            <a:solidFill>
+              <a:schemeClr val="tx1"/>
+            </a:solidFill>
+            <a:prstDash val="solid"/>
+            <a:miter lim="800000"/>
+          </a:ln>
+        </p:spPr>
+        <p:style>
+          <a:lnRef idx="1">
+            <a:schemeClr val="accent1">
+              <a:shade val="50000"/>
+            </a:schemeClr>
+          </a:lnRef>
+          <a:fillRef idx="0">
+            <a:schemeClr val="accent1"/>
+          </a:fillRef>
+          <a:effectRef idx="0">
+            <a:schemeClr val="accent1"/>
+          </a:effectRef>
+          <a:fontRef idx="minor">
+            <a:schemeClr val="tx1"/>
+          </a:fontRef>
+        </p:style>
+      </p:cxnSp>
     </p:spTree>
   </p:cSld>
   <p:clrMapOvr>
@@ -9489,7 +9691,7 @@
 </file>
 
 <file path=ppt/slides/slide2.xml><?xml version="1.0" encoding="utf-8"?>
-<p:sld xmlns:a="http://schemas.openxmlformats.org/drawingml/2006/main" xmlns:r="http://schemas.openxmlformats.org/officeDocument/2006/relationships" xmlns:p="http://schemas.openxmlformats.org/presentationml/2006/main" xmlns:m="http://schemas.openxmlformats.org/officeDocument/2006/math" xmlns:w="http://schemas.openxmlformats.org/wordprocessingml/2006/main" showMasterPhAnim="0" show="1">
+<p:sld xmlns:a="http://schemas.openxmlformats.org/drawingml/2006/main" xmlns:r="http://schemas.openxmlformats.org/officeDocument/2006/relationships" xmlns:p="http://schemas.openxmlformats.org/presentationml/2006/main" xmlns:m="http://schemas.openxmlformats.org/officeDocument/2006/math" xmlns:w="http://schemas.openxmlformats.org/wordprocessingml/2006/main" xmlns:mc="http://schemas.openxmlformats.org/markup-compatibility/2006" showMasterPhAnim="0" showMasterSp="1" show="1">
   <p:cSld name="Slide_1">
     <p:spTree>
       <p:nvGrpSpPr>
@@ -12739,7 +12941,7 @@
 </file>
 
 <file path=ppt/slides/slide3.xml><?xml version="1.0" encoding="utf-8"?>
-<p:sld xmlns:a="http://schemas.openxmlformats.org/drawingml/2006/main" xmlns:r="http://schemas.openxmlformats.org/officeDocument/2006/relationships" xmlns:p="http://schemas.openxmlformats.org/presentationml/2006/main" xmlns:m="http://schemas.openxmlformats.org/officeDocument/2006/math" xmlns:w="http://schemas.openxmlformats.org/wordprocessingml/2006/main" showMasterPhAnim="0" show="1">
+<p:sld xmlns:a="http://schemas.openxmlformats.org/drawingml/2006/main" xmlns:r="http://schemas.openxmlformats.org/officeDocument/2006/relationships" xmlns:p="http://schemas.openxmlformats.org/presentationml/2006/main" xmlns:m="http://schemas.openxmlformats.org/officeDocument/2006/math" xmlns:w="http://schemas.openxmlformats.org/wordprocessingml/2006/main" xmlns:mc="http://schemas.openxmlformats.org/markup-compatibility/2006" showMasterPhAnim="0" showMasterSp="1" show="1">
   <p:cSld name="Slide_1">
     <p:spTree>
       <p:nvGrpSpPr>
@@ -14400,7 +14602,7 @@
 </file>
 
 <file path=ppt/slides/slide4.xml><?xml version="1.0" encoding="utf-8"?>
-<p:sld xmlns:a="http://schemas.openxmlformats.org/drawingml/2006/main" xmlns:r="http://schemas.openxmlformats.org/officeDocument/2006/relationships" xmlns:p="http://schemas.openxmlformats.org/presentationml/2006/main" xmlns:m="http://schemas.openxmlformats.org/officeDocument/2006/math" xmlns:w="http://schemas.openxmlformats.org/wordprocessingml/2006/main" showMasterPhAnim="0" show="1">
+<p:sld xmlns:a="http://schemas.openxmlformats.org/drawingml/2006/main" xmlns:r="http://schemas.openxmlformats.org/officeDocument/2006/relationships" xmlns:p="http://schemas.openxmlformats.org/presentationml/2006/main" xmlns:m="http://schemas.openxmlformats.org/officeDocument/2006/math" xmlns:w="http://schemas.openxmlformats.org/wordprocessingml/2006/main" xmlns:mc="http://schemas.openxmlformats.org/markup-compatibility/2006" showMasterPhAnim="0" showMasterSp="1" show="1">
   <p:cSld name="Slide_1">
     <p:spTree>
       <p:nvGrpSpPr>
@@ -14570,7 +14772,7 @@
         <p:spPr bwMode="auto">
           <a:xfrm>
             <a:off x="5766835" y="1761728"/>
-            <a:ext cx="679276" cy="610160"/>
+            <a:ext cx="679275" cy="610160"/>
           </a:xfrm>
           <a:prstGeom prst="rect">
             <a:avLst/>
@@ -14602,7 +14804,7 @@
         </p:nvSpPr>
         <p:spPr bwMode="auto">
           <a:xfrm>
-            <a:off x="5831631" y="1892759"/>
+            <a:off x="5831630" y="1892759"/>
             <a:ext cx="226820" cy="206158"/>
           </a:xfrm>
           <a:prstGeom prst="rect">
@@ -14836,7 +15038,7 @@
         </p:nvSpPr>
         <p:spPr bwMode="auto">
           <a:xfrm>
-            <a:off x="6040417" y="3261753"/>
+            <a:off x="6040417" y="3261752"/>
             <a:ext cx="226820" cy="208317"/>
           </a:xfrm>
           <a:prstGeom prst="rect">
@@ -14989,7 +15191,7 @@
           <p:nvPr/>
         </p:nvSpPr>
         <p:spPr bwMode="auto">
-          <a:xfrm rot="18899906">
+          <a:xfrm rot="18899905">
             <a:off x="6883742" y="2248353"/>
             <a:ext cx="507926" cy="305159"/>
           </a:xfrm>
@@ -15429,7 +15631,7 @@
 </file>
 
 <file path=ppt/slides/slide5.xml><?xml version="1.0" encoding="utf-8"?>
-<p:sld xmlns:a="http://schemas.openxmlformats.org/drawingml/2006/main" xmlns:r="http://schemas.openxmlformats.org/officeDocument/2006/relationships" xmlns:p="http://schemas.openxmlformats.org/presentationml/2006/main" xmlns:m="http://schemas.openxmlformats.org/officeDocument/2006/math" xmlns:w="http://schemas.openxmlformats.org/wordprocessingml/2006/main" showMasterPhAnim="0" show="1">
+<p:sld xmlns:a="http://schemas.openxmlformats.org/drawingml/2006/main" xmlns:r="http://schemas.openxmlformats.org/officeDocument/2006/relationships" xmlns:p="http://schemas.openxmlformats.org/presentationml/2006/main" xmlns:m="http://schemas.openxmlformats.org/officeDocument/2006/math" xmlns:w="http://schemas.openxmlformats.org/wordprocessingml/2006/main" xmlns:mc="http://schemas.openxmlformats.org/markup-compatibility/2006" showMasterPhAnim="0" showMasterSp="1" show="1">
   <p:cSld name="Slide_1">
     <p:spTree>
       <p:nvGrpSpPr>
@@ -16324,7 +16526,7 @@
         <p:spPr bwMode="auto">
           <a:xfrm>
             <a:off x="3880554" y="1757048"/>
-            <a:ext cx="679276" cy="610160"/>
+            <a:ext cx="679275" cy="610160"/>
           </a:xfrm>
           <a:prstGeom prst="rect">
             <a:avLst/>
@@ -17296,7 +17498,7 @@
         <p:spPr bwMode="auto">
           <a:xfrm>
             <a:off x="2513720" y="1757048"/>
-            <a:ext cx="679276" cy="610160"/>
+            <a:ext cx="679275" cy="610160"/>
           </a:xfrm>
           <a:prstGeom prst="rect">
             <a:avLst/>
@@ -17570,7 +17772,7 @@
         <p:spPr bwMode="auto">
           <a:xfrm>
             <a:off x="4218933" y="3433462"/>
-            <a:ext cx="0" cy="252703"/>
+            <a:ext cx="0" cy="252702"/>
           </a:xfrm>
           <a:prstGeom prst="line">
             <a:avLst/>
@@ -17602,7 +17804,7 @@
         <p:spPr bwMode="auto">
           <a:xfrm>
             <a:off x="2843099" y="3422664"/>
-            <a:ext cx="0" cy="252703"/>
+            <a:ext cx="0" cy="252702"/>
           </a:xfrm>
           <a:prstGeom prst="line">
             <a:avLst/>
@@ -17642,7 +17844,7 @@
 </file>
 
 <file path=ppt/slides/slide6.xml><?xml version="1.0" encoding="utf-8"?>
-<p:sld xmlns:a="http://schemas.openxmlformats.org/drawingml/2006/main" xmlns:r="http://schemas.openxmlformats.org/officeDocument/2006/relationships" xmlns:p="http://schemas.openxmlformats.org/presentationml/2006/main" xmlns:m="http://schemas.openxmlformats.org/officeDocument/2006/math" xmlns:w="http://schemas.openxmlformats.org/wordprocessingml/2006/main" showMasterPhAnim="0" show="1">
+<p:sld xmlns:a="http://schemas.openxmlformats.org/drawingml/2006/main" xmlns:r="http://schemas.openxmlformats.org/officeDocument/2006/relationships" xmlns:p="http://schemas.openxmlformats.org/presentationml/2006/main" xmlns:m="http://schemas.openxmlformats.org/officeDocument/2006/math" xmlns:w="http://schemas.openxmlformats.org/wordprocessingml/2006/main" xmlns:mc="http://schemas.openxmlformats.org/markup-compatibility/2006" showMasterPhAnim="0" showMasterSp="1" show="1">
   <p:cSld name="Slide_1">
     <p:spTree>
       <p:nvGrpSpPr>
@@ -17812,7 +18014,7 @@
         <p:spPr bwMode="auto">
           <a:xfrm>
             <a:off x="5766835" y="1761728"/>
-            <a:ext cx="679276" cy="610160"/>
+            <a:ext cx="679275" cy="610160"/>
           </a:xfrm>
           <a:prstGeom prst="rect">
             <a:avLst/>
@@ -17844,7 +18046,7 @@
         </p:nvSpPr>
         <p:spPr bwMode="auto">
           <a:xfrm>
-            <a:off x="5831631" y="1892759"/>
+            <a:off x="5831630" y="1892759"/>
             <a:ext cx="226820" cy="206158"/>
           </a:xfrm>
           <a:prstGeom prst="rect">
@@ -18078,7 +18280,7 @@
         </p:nvSpPr>
         <p:spPr bwMode="auto">
           <a:xfrm>
-            <a:off x="6040418" y="3261753"/>
+            <a:off x="6040418" y="3261752"/>
             <a:ext cx="226820" cy="208317"/>
           </a:xfrm>
           <a:prstGeom prst="rect">
@@ -18274,7 +18476,7 @@
           <p:nvPr/>
         </p:nvSpPr>
         <p:spPr bwMode="auto">
-          <a:xfrm rot="18899906">
+          <a:xfrm rot="18899905">
             <a:off x="6883742" y="2248177"/>
             <a:ext cx="507567" cy="305151"/>
           </a:xfrm>
@@ -18362,7 +18564,7 @@
         <p:spPr bwMode="auto">
           <a:xfrm>
             <a:off x="3880554" y="1757048"/>
-            <a:ext cx="679276" cy="610160"/>
+            <a:ext cx="679275" cy="610160"/>
           </a:xfrm>
           <a:prstGeom prst="rect">
             <a:avLst/>
@@ -19334,7 +19536,7 @@
         <p:spPr bwMode="auto">
           <a:xfrm>
             <a:off x="2513720" y="1757048"/>
-            <a:ext cx="679276" cy="610160"/>
+            <a:ext cx="679275" cy="610160"/>
           </a:xfrm>
           <a:prstGeom prst="rect">
             <a:avLst/>
@@ -19608,7 +19810,7 @@
         <p:spPr bwMode="auto">
           <a:xfrm>
             <a:off x="4218933" y="3433462"/>
-            <a:ext cx="0" cy="252703"/>
+            <a:ext cx="0" cy="252702"/>
           </a:xfrm>
           <a:prstGeom prst="line">
             <a:avLst/>
@@ -19640,7 +19842,7 @@
         <p:spPr bwMode="auto">
           <a:xfrm>
             <a:off x="2843099" y="3422664"/>
-            <a:ext cx="0" cy="252703"/>
+            <a:ext cx="0" cy="252702"/>
           </a:xfrm>
           <a:prstGeom prst="line">
             <a:avLst/>
@@ -19938,7 +20140,7 @@
         <p:spPr bwMode="auto">
           <a:xfrm rot="16199969" flipH="1" flipV="0">
             <a:off x="6585727" y="4501719"/>
-            <a:ext cx="124088" cy="124088"/>
+            <a:ext cx="124087" cy="124087"/>
           </a:xfrm>
           <a:prstGeom prst="line">
             <a:avLst/>
@@ -19981,7 +20183,7 @@
         <p:spPr bwMode="auto">
           <a:xfrm rot="16199969" flipH="1" flipV="1">
             <a:off x="6585727" y="4501719"/>
-            <a:ext cx="124088" cy="124088"/>
+            <a:ext cx="124087" cy="124087"/>
           </a:xfrm>
           <a:prstGeom prst="line">
             <a:avLst/>
@@ -20028,7 +20230,7 @@
 </file>
 
 <file path=ppt/slides/slide7.xml><?xml version="1.0" encoding="utf-8"?>
-<p:sld xmlns:a="http://schemas.openxmlformats.org/drawingml/2006/main" xmlns:r="http://schemas.openxmlformats.org/officeDocument/2006/relationships" xmlns:p="http://schemas.openxmlformats.org/presentationml/2006/main" xmlns:m="http://schemas.openxmlformats.org/officeDocument/2006/math" xmlns:w="http://schemas.openxmlformats.org/wordprocessingml/2006/main" showMasterPhAnim="0" show="1">
+<p:sld xmlns:a="http://schemas.openxmlformats.org/drawingml/2006/main" xmlns:r="http://schemas.openxmlformats.org/officeDocument/2006/relationships" xmlns:p="http://schemas.openxmlformats.org/presentationml/2006/main" xmlns:m="http://schemas.openxmlformats.org/officeDocument/2006/math" xmlns:w="http://schemas.openxmlformats.org/wordprocessingml/2006/main" xmlns:mc="http://schemas.openxmlformats.org/markup-compatibility/2006" showMasterPhAnim="0" showMasterSp="1" show="1">
   <p:cSld name="Slide_5">
     <p:spTree>
       <p:nvGrpSpPr>
@@ -21705,7 +21907,7 @@
 </file>
 
 <file path=ppt/slides/slide8.xml><?xml version="1.0" encoding="utf-8"?>
-<p:sld xmlns:a="http://schemas.openxmlformats.org/drawingml/2006/main" xmlns:r="http://schemas.openxmlformats.org/officeDocument/2006/relationships" xmlns:p="http://schemas.openxmlformats.org/presentationml/2006/main" xmlns:m="http://schemas.openxmlformats.org/officeDocument/2006/math" xmlns:w="http://schemas.openxmlformats.org/wordprocessingml/2006/main" showMasterPhAnim="0" show="1">
+<p:sld xmlns:a="http://schemas.openxmlformats.org/drawingml/2006/main" xmlns:r="http://schemas.openxmlformats.org/officeDocument/2006/relationships" xmlns:p="http://schemas.openxmlformats.org/presentationml/2006/main" xmlns:m="http://schemas.openxmlformats.org/officeDocument/2006/math" xmlns:w="http://schemas.openxmlformats.org/wordprocessingml/2006/main" xmlns:mc="http://schemas.openxmlformats.org/markup-compatibility/2006" showMasterPhAnim="0" showMasterSp="1" show="1">
   <p:cSld name="Slide_1">
     <p:spTree>
       <p:nvGrpSpPr>
@@ -23359,7 +23561,7 @@
 </file>
 
 <file path=ppt/slides/slide9.xml><?xml version="1.0" encoding="utf-8"?>
-<p:sld xmlns:a="http://schemas.openxmlformats.org/drawingml/2006/main" xmlns:r="http://schemas.openxmlformats.org/officeDocument/2006/relationships" xmlns:p="http://schemas.openxmlformats.org/presentationml/2006/main" xmlns:m="http://schemas.openxmlformats.org/officeDocument/2006/math" xmlns:w="http://schemas.openxmlformats.org/wordprocessingml/2006/main" showMasterPhAnim="0" show="1">
+<p:sld xmlns:a="http://schemas.openxmlformats.org/drawingml/2006/main" xmlns:r="http://schemas.openxmlformats.org/officeDocument/2006/relationships" xmlns:p="http://schemas.openxmlformats.org/presentationml/2006/main" xmlns:m="http://schemas.openxmlformats.org/officeDocument/2006/math" xmlns:w="http://schemas.openxmlformats.org/wordprocessingml/2006/main" xmlns:mc="http://schemas.openxmlformats.org/markup-compatibility/2006" showMasterPhAnim="0" showMasterSp="1" show="1">
   <p:cSld name="Slide_1">
     <p:spTree>
       <p:nvGrpSpPr>
@@ -24734,7 +24936,7 @@
         <p:spPr bwMode="auto">
           <a:xfrm>
             <a:off x="3880554" y="1757048"/>
-            <a:ext cx="679276" cy="610160"/>
+            <a:ext cx="679275" cy="610160"/>
           </a:xfrm>
           <a:prstGeom prst="rect">
             <a:avLst/>
@@ -25706,7 +25908,7 @@
         <p:spPr bwMode="auto">
           <a:xfrm>
             <a:off x="2513720" y="1757048"/>
-            <a:ext cx="679276" cy="610160"/>
+            <a:ext cx="679275" cy="610160"/>
           </a:xfrm>
           <a:prstGeom prst="rect">
             <a:avLst/>
@@ -25980,7 +26182,7 @@
         <p:spPr bwMode="auto">
           <a:xfrm>
             <a:off x="4218933" y="3433462"/>
-            <a:ext cx="0" cy="252703"/>
+            <a:ext cx="0" cy="252702"/>
           </a:xfrm>
           <a:prstGeom prst="line">
             <a:avLst/>
@@ -26012,7 +26214,7 @@
         <p:spPr bwMode="auto">
           <a:xfrm>
             <a:off x="2843099" y="3422664"/>
-            <a:ext cx="0" cy="252703"/>
+            <a:ext cx="0" cy="252702"/>
           </a:xfrm>
           <a:prstGeom prst="line">
             <a:avLst/>

</xml_diff>